<commit_message>
refactor: renumerar bloques y reenfocar bloque3_setup en instalación
- bloque3_agentes -> bloque4_agentes (aporte de compañero)
- bloque4_* (casos prácticos) -> bloque5_*
- Actualizadas referencias cruzadas en README, scripts/ y notebooks
- bloque3_setup ahora se centra en uv, Ollama y el stack de librerías
  en vez de terminar con un repaso del ciclo de análisis completo
- uv.lock actualizado tras uv sync (dependencia crewai)
- .gitignore: excluir correcciones.txt (notas locales por bloque)
</commit_message>
<xml_diff>
--- a/bloque3_setup/csbc26_b3_setup.pptx
+++ b/bloque3_setup/csbc26_b3_setup.pptx
@@ -19,6 +19,8 @@
     <p:sldId id="264" r:id="rId19"/>
     <p:sldId id="265" r:id="rId20"/>
     <p:sldId id="266" r:id="rId21"/>
+    <p:sldId id="267" r:id="rId22"/>
+    <p:sldId id="268" r:id="rId23"/>
   </p:sldIdLst>
   <p:sldSz cx="12192000" cy="6858000"/>
   <p:notesSz cx="6858000" cy="9144000"/>
@@ -717,17 +719,17 @@
           </a:p>
           <a:p>
             <a:r>
-              <a:t>45 min: entorno completo en vivo, sin atajos</a:t>
-            </a:r>
-          </a:p>
-          <a:p>
-            <a:r>
-              <a:t>Pregunta: ¿cuánto tardaríais replicando esto solos?</a:t>
-            </a:r>
-          </a:p>
-          <a:p>
-            <a:r>
-              <a:t>→ uv + Ollama + Jupyter = 10 minutos, demo en vivo</a:t>
+              <a:t>45 min: no repasamos el ciclo de análisis, eso ya se vio</a:t>
+            </a:r>
+          </a:p>
+          <a:p>
+            <a:r>
+              <a:t>Objetivo: instalar el entorno y entender qué es cada pieza</a:t>
+            </a:r>
+          </a:p>
+          <a:p>
+            <a:r>
+              <a:t>→ uv, Ollama, librerías clave</a:t>
             </a:r>
           </a:p>
         </p:txBody>
@@ -797,27 +799,22 @@
           <a:lstStyle/>
           <a:p>
             <a:r>
-              <a:t>Manos a la obra — notebook 00_reconocimiento</a:t>
-            </a:r>
-          </a:p>
-          <a:p>
-            <a:r>
-              <a:t>5 secciones en directo: carga, power-law, grafo brokers</a:t>
-            </a:r>
-          </a:p>
-          <a:p>
-            <a:r>
-              <a:t>Embeddings ejecutándose de verdad (muestra 100)</a:t>
-            </a:r>
-          </a:p>
-          <a:p>
-            <a:r>
-              <a:t>→ UMAP + clustering Plotly</a:t>
-            </a:r>
-          </a:p>
-          <a:p>
-            <a:r>
-              <a:t>Si falla en vivo: comentamos y seguimos, es laboratorio</a:t>
+              <a:t>18 dependencias en total, esto es el grupo específico del curso</a:t>
+            </a:r>
+          </a:p>
+          <a:p>
+            <a:r>
+              <a:t>pandas/matplotlib/sklearn ya los conocen</a:t>
+            </a:r>
+          </a:p>
+          <a:p>
+            <a:r>
+              <a:t>→ cada una resuelve un problema puntual del pipeline</a:t>
+            </a:r>
+          </a:p>
+          <a:p>
+            <a:r>
+              <a:t>chromadb y umap-learn son las menos obvias, detenerse ahí</a:t>
             </a:r>
           </a:p>
         </p:txBody>
@@ -887,6 +884,176 @@
           <a:lstStyle/>
           <a:p>
             <a:r>
+              <a:t>Tranquilizar: no hace falta gama alta</a:t>
+            </a:r>
+          </a:p>
+          <a:p>
+            <a:r>
+              <a:t>8GB RAM + CPU moderna = suficiente para pandas/networkx</a:t>
+            </a:r>
+          </a:p>
+          <a:p>
+            <a:r>
+              <a:t>Derecha: solo si embeddings + LLM local</a:t>
+            </a:r>
+          </a:p>
+          <a:p>
+            <a:r>
+              <a:t>→ sin GPU funciona, más lento, sobre muestra es instantáneo</a:t>
+            </a:r>
+          </a:p>
+        </p:txBody>
+      </p:sp>
+      <p:sp>
+        <p:nvSpPr>
+          <p:cNvPr id="4" name="Slide Number Placeholder 3"/>
+          <p:cNvSpPr>
+            <a:spLocks noGrp="1"/>
+          </p:cNvSpPr>
+          <p:nvPr>
+            <p:ph type="sldNum" idx="5" sz="quarter"/>
+          </p:nvPr>
+        </p:nvSpPr>
+        <p:spPr/>
+      </p:sp>
+    </p:spTree>
+  </p:cSld>
+  <p:clrMapOvr>
+    <a:masterClrMapping/>
+  </p:clrMapOvr>
+</p:notes>
+</file>
+
+<file path=ppt/notesSlides/notesSlide12.xml><?xml version="1.0" encoding="utf-8"?>
+<p:notes xmlns:a="http://schemas.openxmlformats.org/drawingml/2006/main" xmlns:p="http://schemas.openxmlformats.org/presentationml/2006/main" xmlns:r="http://schemas.openxmlformats.org/officeDocument/2006/relationships">
+  <p:cSld>
+    <p:spTree>
+      <p:nvGrpSpPr>
+        <p:cNvPr id="1" name=""/>
+        <p:cNvGrpSpPr/>
+        <p:nvPr/>
+      </p:nvGrpSpPr>
+      <p:grpSpPr>
+        <a:xfrm>
+          <a:off x="0" y="0"/>
+          <a:ext cx="0" cy="0"/>
+          <a:chOff x="0" y="0"/>
+          <a:chExt cx="0" cy="0"/>
+        </a:xfrm>
+      </p:grpSpPr>
+      <p:sp>
+        <p:nvSpPr>
+          <p:cNvPr id="2" name="Slide Image Placeholder 1"/>
+          <p:cNvSpPr>
+            <a:spLocks noGrp="1"/>
+          </p:cNvSpPr>
+          <p:nvPr>
+            <p:ph type="sldImg" idx="2"/>
+          </p:nvPr>
+        </p:nvSpPr>
+        <p:spPr/>
+      </p:sp>
+      <p:sp>
+        <p:nvSpPr>
+          <p:cNvPr id="3" name="Notes Placeholder 2"/>
+          <p:cNvSpPr>
+            <a:spLocks noGrp="1"/>
+          </p:cNvSpPr>
+          <p:nvPr>
+            <p:ph type="body" idx="3" sz="quarter"/>
+          </p:nvPr>
+        </p:nvSpPr>
+        <p:spPr/>
+        <p:txBody>
+          <a:bodyPr/>
+          <a:lstStyle/>
+          <a:p>
+            <a:r>
+              <a:t>No analiza datos reales — datos sintéticos mínimos, corre en segundos</a:t>
+            </a:r>
+          </a:p>
+          <a:p>
+            <a:r>
+              <a:t>Si algo falla: Ollama no está corriendo o falta un modelo</a:t>
+            </a:r>
+          </a:p>
+          <a:p>
+            <a:r>
+              <a:t>→ resolverlo aquí, no en el primer caso práctico</a:t>
+            </a:r>
+          </a:p>
+          <a:p>
+            <a:r>
+              <a:t>Cada alumno confirma su propio entorno antes de seguir</a:t>
+            </a:r>
+          </a:p>
+        </p:txBody>
+      </p:sp>
+      <p:sp>
+        <p:nvSpPr>
+          <p:cNvPr id="4" name="Slide Number Placeholder 3"/>
+          <p:cNvSpPr>
+            <a:spLocks noGrp="1"/>
+          </p:cNvSpPr>
+          <p:nvPr>
+            <p:ph type="sldNum" idx="5" sz="quarter"/>
+          </p:nvPr>
+        </p:nvSpPr>
+        <p:spPr/>
+      </p:sp>
+    </p:spTree>
+  </p:cSld>
+  <p:clrMapOvr>
+    <a:masterClrMapping/>
+  </p:clrMapOvr>
+</p:notes>
+</file>
+
+<file path=ppt/notesSlides/notesSlide13.xml><?xml version="1.0" encoding="utf-8"?>
+<p:notes xmlns:a="http://schemas.openxmlformats.org/drawingml/2006/main" xmlns:p="http://schemas.openxmlformats.org/presentationml/2006/main" xmlns:r="http://schemas.openxmlformats.org/officeDocument/2006/relationships">
+  <p:cSld>
+    <p:spTree>
+      <p:nvGrpSpPr>
+        <p:cNvPr id="1" name=""/>
+        <p:cNvGrpSpPr/>
+        <p:nvPr/>
+      </p:nvGrpSpPr>
+      <p:grpSpPr>
+        <a:xfrm>
+          <a:off x="0" y="0"/>
+          <a:ext cx="0" cy="0"/>
+          <a:chOff x="0" y="0"/>
+          <a:chExt cx="0" cy="0"/>
+        </a:xfrm>
+      </p:grpSpPr>
+      <p:sp>
+        <p:nvSpPr>
+          <p:cNvPr id="2" name="Slide Image Placeholder 1"/>
+          <p:cNvSpPr>
+            <a:spLocks noGrp="1"/>
+          </p:cNvSpPr>
+          <p:nvPr>
+            <p:ph type="sldImg" idx="2"/>
+          </p:nvPr>
+        </p:nvSpPr>
+        <p:spPr/>
+      </p:sp>
+      <p:sp>
+        <p:nvSpPr>
+          <p:cNvPr id="3" name="Notes Placeholder 2"/>
+          <p:cNvSpPr>
+            <a:spLocks noGrp="1"/>
+          </p:cNvSpPr>
+          <p:nvPr>
+            <p:ph type="body" idx="3" sz="quarter"/>
+          </p:nvPr>
+        </p:nvSpPr>
+        <p:spPr/>
+        <p:txBody>
+          <a:bodyPr/>
+          <a:lstStyle/>
+          <a:p>
+            <a:r>
               <a:t>Cierre: preguntas frecuentes, respuestas sin vender humo</a:t>
             </a:r>
           </a:p>
@@ -907,7 +1074,7 @@
           </a:p>
           <a:p>
             <a:r>
-              <a:t>Datos: canal separado, nunca en el repo</a:t>
+              <a:t>Entorno listo → Bloque 4 (agentes) y Bloque 5 (casos prácticos)</a:t>
             </a:r>
           </a:p>
         </p:txBody>
@@ -977,7 +1144,7 @@
           <a:lstStyle/>
           <a:p>
             <a:r>
-              <a:t>Piezas del entorno, una por una</a:t>
+              <a:t>Primera pieza: uv</a:t>
             </a:r>
           </a:p>
           <a:p>
@@ -1077,7 +1244,7 @@
           </a:p>
           <a:p>
             <a:r>
-              <a:t>Mismo entorno en cualquier portátil</a:t>
+              <a:t>Esta parte es corta a propósito — funciona a la primera</a:t>
             </a:r>
           </a:p>
         </p:txBody>
@@ -1147,22 +1314,17 @@
           <a:lstStyle/>
           <a:p>
             <a:r>
-              <a:t>4 comandos, literalmente los únicos</a:t>
-            </a:r>
-          </a:p>
-          <a:p>
-            <a:r>
-              <a:t>Clonar → uv sync → pull modelos → Jupyter</a:t>
-            </a:r>
-          </a:p>
-          <a:p>
-            <a:r>
-              <a:t>Cuello de botella: descarga modelos (~9GB), no Python</a:t>
-            </a:r>
-          </a:p>
-          <a:p>
-            <a:r>
-              <a:t>→ descargar la noche antes, no en vivo</a:t>
+              <a:t>3 comandos, literalmente los únicos</a:t>
+            </a:r>
+          </a:p>
+          <a:p>
+            <a:r>
+              <a:t>Clonar → uv sync → Jupyter</a:t>
+            </a:r>
+          </a:p>
+          <a:p>
+            <a:r>
+              <a:t>Sin git: ZIP desde GitHub, copiar data/ y results/ aparte</a:t>
             </a:r>
           </a:p>
         </p:txBody>
@@ -1232,27 +1394,12 @@
           <a:lstStyle/>
           <a:p>
             <a:r>
-              <a:t>Tranquilizar: no hace falta gama alta</a:t>
-            </a:r>
-          </a:p>
-          <a:p>
-            <a:r>
-              <a:t>8GB RAM + CPU moderna = suficiente para pandas/networkx</a:t>
-            </a:r>
-          </a:p>
-          <a:p>
-            <a:r>
-              <a:t>Derecha: solo si embeddings + LLM local</a:t>
-            </a:r>
-          </a:p>
-          <a:p>
-            <a:r>
-              <a:t>→ sin GPU funciona, más lento</a:t>
-            </a:r>
-          </a:p>
-          <a:p>
-            <a:r>
-              <a:t>Demo con muestra pequeña, fluida en cualquier portátil</a:t>
+              <a:t>Segunda pieza: Ollama</a:t>
+            </a:r>
+          </a:p>
+          <a:p>
+            <a:r>
+              <a:t>Qué es, para qué sirve, por qué es obligatorio con estos datos</a:t>
             </a:r>
           </a:p>
         </p:txBody>
@@ -1322,22 +1469,22 @@
           <a:lstStyle/>
           <a:p>
             <a:r>
-              <a:t>Honestidad sobre la demo</a:t>
-            </a:r>
-          </a:p>
-          <a:p>
-            <a:r>
-              <a:t>Embeddings completos: precomputados (horas si no)</a:t>
-            </a:r>
-          </a:p>
-          <a:p>
-            <a:r>
-              <a:t>En vivo: mismo código sobre muestra 100 usuarios</a:t>
-            </a:r>
-          </a:p>
-          <a:p>
-            <a:r>
-              <a:t>→ objetivo no es velocidad, es pipeline real y reproducible</a:t>
+              <a:t>Ollama = LLM en local, sin mandar datos afuera</a:t>
+            </a:r>
+          </a:p>
+          <a:p>
+            <a:r>
+              <a:t>Servidor en localhost:11434, cliente Python normal</a:t>
+            </a:r>
+          </a:p>
+          <a:p>
+            <a:r>
+              <a:t>→ es lo que hace viable trabajar con leaks sensibles</a:t>
+            </a:r>
+          </a:p>
+          <a:p>
+            <a:r>
+              <a:t>No es un detalle técnico, es la premisa ética del curso</a:t>
             </a:r>
           </a:p>
         </p:txBody>
@@ -1407,22 +1554,22 @@
           <a:lstStyle/>
           <a:p>
             <a:r>
-              <a:t>Entorno ya montado</a:t>
-            </a:r>
-          </a:p>
-          <a:p>
-            <a:r>
-              <a:t>Ahora: pipeline entero</a:t>
-            </a:r>
-          </a:p>
-          <a:p>
-            <a:r>
-              <a:t>Dump SQL → visualización final</a:t>
-            </a:r>
-          </a:p>
-          <a:p>
-            <a:r>
-              <a:t>→ celda por celda, sin saltos</a:t>
+              <a:t>Dos modelos, dos propósitos, no se solapan</a:t>
+            </a:r>
+          </a:p>
+          <a:p>
+            <a:r>
+              <a:t>qwen3-embedding: vectores. qwen2.5:14b: texto→texto</a:t>
+            </a:r>
+          </a:p>
+          <a:p>
+            <a:r>
+              <a:t>→ ~9GB entre los dos, descargar la noche antes</a:t>
+            </a:r>
+          </a:p>
+          <a:p>
+            <a:r>
+              <a:t>ollama pull &lt;modelo&gt; — mostrar y cortar con Ctrl+C</a:t>
             </a:r>
           </a:p>
         </p:txBody>
@@ -1492,22 +1639,17 @@
           <a:lstStyle/>
           <a:p>
             <a:r>
-              <a:t>Esqueleto de cualquier análisis del curso, no solo hoy</a:t>
-            </a:r>
-          </a:p>
-          <a:p>
-            <a:r>
-              <a:t>Load → Normalize → Analyze → Embed → Visualize</a:t>
-            </a:r>
-          </a:p>
-          <a:p>
-            <a:r>
-              <a:t>→ todo en el mismo notebook, sin cambiar de herramienta</a:t>
-            </a:r>
-          </a:p>
-          <a:p>
-            <a:r>
-              <a:t>Un solo lugar, todo el razonamiento visible</a:t>
+              <a:t>Dos formas de usarlo: código (ollama-python) o terminal (llm CLI)</a:t>
+            </a:r>
+          </a:p>
+          <a:p>
+            <a:r>
+              <a:t>src/embeddings.py y src/utils.py son los puntos de entrada</a:t>
+            </a:r>
+          </a:p>
+          <a:p>
+            <a:r>
+              <a:t>→ llm CLI para tareas ad-hoc, ver ollama_llm_cli.md</a:t>
             </a:r>
           </a:p>
         </p:txBody>
@@ -1577,22 +1719,12 @@
           <a:lstStyle/>
           <a:p>
             <a:r>
-              <a:t>¿Por qué este dataset y no el grande?</a:t>
-            </a:r>
-          </a:p>
-          <a:p>
-            <a:r>
-              <a:t>Objetivo: pipeline completo, sin esperar precomputo</a:t>
-            </a:r>
-          </a:p>
-          <a:p>
-            <a:r>
-              <a:t>Pequeño, schema limpio, sin variantes problemáticas</a:t>
-            </a:r>
-          </a:p>
-          <a:p>
-            <a:r>
-              <a:t>→ estructura idéntica a casos reales del curso</a:t>
+              <a:t>Tercera pieza: las librerías</a:t>
+            </a:r>
+          </a:p>
+          <a:p>
+            <a:r>
+              <a:t>No todas — solo las que no son de uso general</a:t>
             </a:r>
           </a:p>
         </p:txBody>
@@ -5211,7 +5343,7 @@
           <a:lstStyle/>
           <a:p>
             <a:r>
-              <a:t>Setup y demo en vivo</a:t>
+              <a:t>Setup del entorno y herramientas</a:t>
             </a:r>
           </a:p>
           <a:p>
@@ -5222,7 +5354,7 @@
                 </a:solidFill>
                 <a:latin typeface="Arial"/>
               </a:rPr>
-              <a:t>El entorno completo en 10 minutos — uv + Ollama + Jupyter</a:t>
+              <a:t>uv + Ollama + el stack de análisis — instalado y entendido</a:t>
             </a:r>
           </a:p>
           <a:p>
@@ -5263,7 +5395,7 @@
             <a:spLocks noGrp="1"/>
           </p:cNvSpPr>
           <p:nvPr>
-            <p:ph type="body" idx="10" sz="quarter"/>
+            <p:ph type="body" idx="13" sz="quarter"/>
           </p:nvPr>
         </p:nvSpPr>
         <p:spPr/>
@@ -5271,122 +5403,64 @@
           <a:bodyPr wrap="square"/>
           <a:lstStyle/>
           <a:p>
-            <a:pPr algn="ctr"/>
-            <a:r>
-              <a:rPr sz="1300" b="1">
-                <a:solidFill>
-                  <a:srgbClr val="CD2D37"/>
-                </a:solidFill>
-                <a:latin typeface="Arial"/>
-              </a:rPr>
-              <a:t>DEMO EN VIVO</a:t>
-            </a:r>
-          </a:p>
-          <a:p>
-            <a:pPr algn="ctr"/>
-            <a:r>
-              <a:t>Demo en vivo — pipeline completo</a:t>
-            </a:r>
-          </a:p>
-          <a:p>
-            <a:pPr algn="ctr"/>
-            <a:r>
-              <a:rPr sz="1400">
-                <a:solidFill>
-                  <a:srgbClr val="9AA3B5"/>
-                </a:solidFill>
-                <a:latin typeface="Arial"/>
-              </a:rPr>
-              <a:t>&lt;caso_demo&gt;/00_reconocimiento.ipynb</a:t>
-            </a:r>
-          </a:p>
-        </p:txBody>
-      </p:sp>
-      <p:sp>
-        <p:nvSpPr>
-          <p:cNvPr id="3" name="TextBox 2"/>
-          <p:cNvSpPr txBox="1"/>
-          <p:nvPr/>
+            <a:r>
+              <a:t>Librerías clave del proyecto</a:t>
+            </a:r>
+          </a:p>
+        </p:txBody>
+      </p:sp>
+      <p:sp>
+        <p:nvSpPr>
+          <p:cNvPr id="3" name="Text Placeholder 2"/>
+          <p:cNvSpPr>
+            <a:spLocks noGrp="1"/>
+          </p:cNvSpPr>
+          <p:nvPr>
+            <p:ph type="body" idx="16" sz="quarter"/>
+          </p:nvPr>
         </p:nvSpPr>
         <p:spPr>
           <a:xfrm>
-            <a:off x="2505456" y="3657600"/>
-            <a:ext cx="7168896" cy="2560320"/>
+            <a:off x="1073427" y="2214736"/>
+            <a:ext cx="10084904" cy="3370138"/>
           </a:xfrm>
-          <a:prstGeom prst="rect">
-            <a:avLst/>
-          </a:prstGeom>
-          <a:noFill/>
         </p:spPr>
         <p:txBody>
-          <a:bodyPr wrap="square">
-            <a:spAutoFit/>
-          </a:bodyPr>
+          <a:bodyPr wrap="square"/>
           <a:lstStyle/>
           <a:p>
             <a:r>
-              <a:rPr sz="1600">
-                <a:solidFill>
-                  <a:srgbClr val="D6DAE2"/>
-                </a:solidFill>
-                <a:latin typeface="Arial"/>
-              </a:rPr>
-              <a:t>1.  Abrir el notebook 00_reconocimiento del caso de demo</a:t>
-            </a:r>
-          </a:p>
-          <a:p>
-            <a:r>
-              <a:rPr sz="1600">
-                <a:solidFill>
-                  <a:srgbClr val="D6DAE2"/>
-                </a:solidFill>
-                <a:latin typeface="Arial"/>
-              </a:rPr>
-              <a:t>2.  Sección 1: load_forum() → ver auto-detección de formato en los logs</a:t>
-            </a:r>
-          </a:p>
-          <a:p>
-            <a:r>
-              <a:rPr sz="1600">
-                <a:solidFill>
-                  <a:srgbClr val="D6DAE2"/>
-                </a:solidFill>
-                <a:latin typeface="Arial"/>
-              </a:rPr>
-              <a:t>3.  Sección 2: distribución de usuarios y posts — power-law visible</a:t>
-            </a:r>
-          </a:p>
-          <a:p>
-            <a:r>
-              <a:rPr sz="1600">
-                <a:solidFill>
-                  <a:srgbClr val="D6DAE2"/>
-                </a:solidFill>
-                <a:latin typeface="Arial"/>
-              </a:rPr>
-              <a:t>4.  Sección 3: grafo de co-participación — identificar brokers</a:t>
-            </a:r>
-          </a:p>
-          <a:p>
-            <a:r>
-              <a:rPr sz="1600">
-                <a:solidFill>
-                  <a:srgbClr val="D6DAE2"/>
-                </a:solidFill>
-                <a:latin typeface="Arial"/>
-              </a:rPr>
-              <a:t>5.  Sección 4: embeddings sobre muestra de 100 usuarios (ejecutar en vivo)</a:t>
-            </a:r>
-          </a:p>
-          <a:p>
-            <a:r>
-              <a:rPr sz="1600">
-                <a:solidFill>
-                  <a:srgbClr val="D6DAE2"/>
-                </a:solidFill>
-                <a:latin typeface="Arial"/>
-              </a:rPr>
-              <a:t>6.  Sección 5: UMAP + clustering — visualización interactiva Plotly</a:t>
+              <a:t>ollama — cliente Python del servidor Ollama</a:t>
+            </a:r>
+          </a:p>
+          <a:p>
+            <a:r>
+              <a:t>chromadb — base de datos vectorial local, búsqueda por similitud sin infraestructura</a:t>
+            </a:r>
+          </a:p>
+          <a:p>
+            <a:r>
+              <a:t>umap-learn — reduce embeddings de alta dimensión a 2D para visualizar clusters</a:t>
+            </a:r>
+          </a:p>
+          <a:p>
+            <a:r>
+              <a:t>hdbscan — clustering por densidad, sin fijar K de antemano</a:t>
+            </a:r>
+          </a:p>
+          <a:p>
+            <a:r>
+              <a:t>bertopic — topic modeling sobre embeddings, alternativa a LDA con vocabulario ruidoso</a:t>
+            </a:r>
+          </a:p>
+          <a:p>
+            <a:r>
+              <a:t>langdetect — detección de idioma para la decisión original vs. traducción</a:t>
+            </a:r>
+          </a:p>
+          <a:p>
+            <a:r>
+              <a:t>crewai — orquestación de agentes de IA sobre Ollama (Bloque 4)</a:t>
             </a:r>
           </a:p>
         </p:txBody>
@@ -5425,7 +5499,7 @@
           <a:lstStyle/>
           <a:p>
             <a:r>
-              <a:t>Preguntas frecuentes y respuestas honestas</a:t>
+              <a:t>Requisitos de hardware — no hace falta potencia</a:t>
             </a:r>
           </a:p>
         </p:txBody>
@@ -5439,11 +5513,525 @@
           <p:nvPr>
             <p:ph type="body" idx="16" sz="quarter"/>
           </p:nvPr>
+        </p:nvSpPr>
+        <p:spPr/>
+        <p:txBody>
+          <a:bodyPr/>
+          <a:lstStyle/>
+          <a:p/>
+        </p:txBody>
+      </p:sp>
+      <p:sp>
+        <p:nvSpPr>
+          <p:cNvPr id="4" name="TextBox 3"/>
+          <p:cNvSpPr txBox="1"/>
+          <p:nvPr/>
         </p:nvSpPr>
         <p:spPr>
           <a:xfrm>
-            <a:off x="1073427" y="2077576"/>
-            <a:ext cx="10084904" cy="3507298"/>
+            <a:off x="1051560" y="2331720"/>
+            <a:ext cx="4846320" cy="411480"/>
+          </a:xfrm>
+          <a:prstGeom prst="rect">
+            <a:avLst/>
+          </a:prstGeom>
+          <a:noFill/>
+        </p:spPr>
+        <p:txBody>
+          <a:bodyPr wrap="square">
+            <a:spAutoFit/>
+          </a:bodyPr>
+          <a:lstStyle/>
+          <a:p>
+            <a:pPr algn="l"/>
+            <a:r>
+              <a:rPr sz="1600" b="1">
+                <a:solidFill>
+                  <a:srgbClr val="CD2D37"/>
+                </a:solidFill>
+                <a:latin typeface="Arial"/>
+              </a:rPr>
+              <a:t>Mínimo (análisis pandas/networkx)</a:t>
+            </a:r>
+          </a:p>
+        </p:txBody>
+      </p:sp>
+      <p:sp>
+        <p:nvSpPr>
+          <p:cNvPr id="5" name="TextBox 4"/>
+          <p:cNvSpPr txBox="1"/>
+          <p:nvPr/>
+        </p:nvSpPr>
+        <p:spPr>
+          <a:xfrm>
+            <a:off x="1051560" y="2788920"/>
+            <a:ext cx="4846320" cy="3200400"/>
+          </a:xfrm>
+          <a:prstGeom prst="rect">
+            <a:avLst/>
+          </a:prstGeom>
+          <a:noFill/>
+        </p:spPr>
+        <p:txBody>
+          <a:bodyPr wrap="square">
+            <a:spAutoFit/>
+          </a:bodyPr>
+          <a:lstStyle/>
+          <a:p>
+            <a:r>
+              <a:rPr sz="1600">
+                <a:solidFill>
+                  <a:srgbClr val="CD2D37"/>
+                </a:solidFill>
+                <a:latin typeface="Arial"/>
+              </a:rPr>
+              <a:t>▸  </a:t>
+            </a:r>
+            <a:r>
+              <a:rPr sz="1600">
+                <a:solidFill>
+                  <a:srgbClr val="465461"/>
+                </a:solidFill>
+                <a:latin typeface="Arial"/>
+              </a:rPr>
+              <a:t>8GB RAM</a:t>
+            </a:r>
+          </a:p>
+          <a:p>
+            <a:r>
+              <a:rPr sz="1600">
+                <a:solidFill>
+                  <a:srgbClr val="CD2D37"/>
+                </a:solidFill>
+                <a:latin typeface="Arial"/>
+              </a:rPr>
+              <a:t>▸  </a:t>
+            </a:r>
+            <a:r>
+              <a:rPr sz="1600">
+                <a:solidFill>
+                  <a:srgbClr val="465461"/>
+                </a:solidFill>
+                <a:latin typeface="Arial"/>
+              </a:rPr>
+              <a:t>Cualquier CPU moderna</a:t>
+            </a:r>
+          </a:p>
+          <a:p>
+            <a:r>
+              <a:rPr sz="1600">
+                <a:solidFill>
+                  <a:srgbClr val="CD2D37"/>
+                </a:solidFill>
+                <a:latin typeface="Arial"/>
+              </a:rPr>
+              <a:t>▸  </a:t>
+            </a:r>
+            <a:r>
+              <a:rPr sz="1600">
+                <a:solidFill>
+                  <a:srgbClr val="465461"/>
+                </a:solidFill>
+                <a:latin typeface="Arial"/>
+              </a:rPr>
+              <a:t>10GB disco libre para datos y modelos</a:t>
+            </a:r>
+          </a:p>
+          <a:p>
+            <a:r>
+              <a:rPr sz="1600">
+                <a:solidFill>
+                  <a:srgbClr val="CD2D37"/>
+                </a:solidFill>
+                <a:latin typeface="Arial"/>
+              </a:rPr>
+              <a:t>▸  </a:t>
+            </a:r>
+            <a:r>
+              <a:rPr sz="1600">
+                <a:solidFill>
+                  <a:srgbClr val="465461"/>
+                </a:solidFill>
+                <a:latin typeface="Arial"/>
+              </a:rPr>
+              <a:t>Python 3.12+</a:t>
+            </a:r>
+          </a:p>
+          <a:p>
+            <a:r>
+              <a:rPr sz="1600">
+                <a:solidFill>
+                  <a:srgbClr val="CD2D37"/>
+                </a:solidFill>
+                <a:latin typeface="Arial"/>
+              </a:rPr>
+              <a:t>▸  </a:t>
+            </a:r>
+            <a:r>
+              <a:rPr sz="1600">
+                <a:solidFill>
+                  <a:srgbClr val="465461"/>
+                </a:solidFill>
+                <a:latin typeface="Arial"/>
+              </a:rPr>
+              <a:t>EDA, grafos, text mining: fluidos</a:t>
+            </a:r>
+          </a:p>
+        </p:txBody>
+      </p:sp>
+      <p:sp>
+        <p:nvSpPr>
+          <p:cNvPr id="6" name="TextBox 5"/>
+          <p:cNvSpPr txBox="1"/>
+          <p:nvPr/>
+        </p:nvSpPr>
+        <p:spPr>
+          <a:xfrm>
+            <a:off x="6217920" y="2331720"/>
+            <a:ext cx="4846320" cy="411480"/>
+          </a:xfrm>
+          <a:prstGeom prst="rect">
+            <a:avLst/>
+          </a:prstGeom>
+          <a:noFill/>
+        </p:spPr>
+        <p:txBody>
+          <a:bodyPr wrap="square">
+            <a:spAutoFit/>
+          </a:bodyPr>
+          <a:lstStyle/>
+          <a:p>
+            <a:pPr algn="l"/>
+            <a:r>
+              <a:rPr sz="1600" b="1">
+                <a:solidFill>
+                  <a:srgbClr val="CD2D37"/>
+                </a:solidFill>
+                <a:latin typeface="Arial"/>
+              </a:rPr>
+              <a:t>Recomendado (embeddings + LLM)</a:t>
+            </a:r>
+          </a:p>
+        </p:txBody>
+      </p:sp>
+      <p:sp>
+        <p:nvSpPr>
+          <p:cNvPr id="7" name="TextBox 6"/>
+          <p:cNvSpPr txBox="1"/>
+          <p:nvPr/>
+        </p:nvSpPr>
+        <p:spPr>
+          <a:xfrm>
+            <a:off x="6217920" y="2788920"/>
+            <a:ext cx="4846320" cy="3200400"/>
+          </a:xfrm>
+          <a:prstGeom prst="rect">
+            <a:avLst/>
+          </a:prstGeom>
+          <a:noFill/>
+        </p:spPr>
+        <p:txBody>
+          <a:bodyPr wrap="square">
+            <a:spAutoFit/>
+          </a:bodyPr>
+          <a:lstStyle/>
+          <a:p>
+            <a:r>
+              <a:rPr sz="1600">
+                <a:solidFill>
+                  <a:srgbClr val="CD2D37"/>
+                </a:solidFill>
+                <a:latin typeface="Arial"/>
+              </a:rPr>
+              <a:t>▸  </a:t>
+            </a:r>
+            <a:r>
+              <a:rPr sz="1600">
+                <a:solidFill>
+                  <a:srgbClr val="465461"/>
+                </a:solidFill>
+                <a:latin typeface="Arial"/>
+              </a:rPr>
+              <a:t>16GB RAM para qwen2.5:14b Q4</a:t>
+            </a:r>
+          </a:p>
+          <a:p>
+            <a:r>
+              <a:rPr sz="1600">
+                <a:solidFill>
+                  <a:srgbClr val="CD2D37"/>
+                </a:solidFill>
+                <a:latin typeface="Arial"/>
+              </a:rPr>
+              <a:t>▸  </a:t>
+            </a:r>
+            <a:r>
+              <a:rPr sz="1600">
+                <a:solidFill>
+                  <a:srgbClr val="465461"/>
+                </a:solidFill>
+                <a:latin typeface="Arial"/>
+              </a:rPr>
+              <a:t>GPU opcional (acelera embeddings ×10)</a:t>
+            </a:r>
+          </a:p>
+          <a:p>
+            <a:r>
+              <a:rPr sz="1600">
+                <a:solidFill>
+                  <a:srgbClr val="CD2D37"/>
+                </a:solidFill>
+                <a:latin typeface="Arial"/>
+              </a:rPr>
+              <a:t>▸  </a:t>
+            </a:r>
+            <a:r>
+              <a:rPr sz="1600">
+                <a:solidFill>
+                  <a:srgbClr val="465461"/>
+                </a:solidFill>
+                <a:latin typeface="Arial"/>
+              </a:rPr>
+              <a:t>25GB disco para todos los modelos</a:t>
+            </a:r>
+          </a:p>
+          <a:p>
+            <a:r>
+              <a:rPr sz="1600">
+                <a:solidFill>
+                  <a:srgbClr val="CD2D37"/>
+                </a:solidFill>
+                <a:latin typeface="Arial"/>
+              </a:rPr>
+              <a:t>▸  </a:t>
+            </a:r>
+            <a:r>
+              <a:rPr sz="1600">
+                <a:solidFill>
+                  <a:srgbClr val="465461"/>
+                </a:solidFill>
+                <a:latin typeface="Arial"/>
+              </a:rPr>
+              <a:t>Embeddings en CPU: lentos pero funcionales</a:t>
+            </a:r>
+          </a:p>
+          <a:p>
+            <a:r>
+              <a:rPr sz="1600">
+                <a:solidFill>
+                  <a:srgbClr val="CD2D37"/>
+                </a:solidFill>
+                <a:latin typeface="Arial"/>
+              </a:rPr>
+              <a:t>▸  </a:t>
+            </a:r>
+            <a:r>
+              <a:rPr sz="1600">
+                <a:solidFill>
+                  <a:srgbClr val="465461"/>
+                </a:solidFill>
+                <a:latin typeface="Arial"/>
+              </a:rPr>
+              <a:t>Sobre muestra pequeña: instantáneo en cualquier hardware</a:t>
+            </a:r>
+          </a:p>
+        </p:txBody>
+      </p:sp>
+    </p:spTree>
+  </p:cSld>
+  <p:clrMapOvr>
+    <a:masterClrMapping/>
+  </p:clrMapOvr>
+</p:sld>
+</file>
+
+<file path=ppt/slides/slide12.xml><?xml version="1.0" encoding="utf-8"?>
+<p:sld xmlns:a="http://schemas.openxmlformats.org/drawingml/2006/main" xmlns:p="http://schemas.openxmlformats.org/presentationml/2006/main" xmlns:r="http://schemas.openxmlformats.org/officeDocument/2006/relationships">
+  <p:cSld>
+    <p:spTree>
+      <p:nvGrpSpPr>
+        <p:cNvPr id="1" name=""/>
+        <p:cNvGrpSpPr/>
+        <p:nvPr/>
+      </p:nvGrpSpPr>
+      <p:grpSpPr/>
+      <p:sp>
+        <p:nvSpPr>
+          <p:cNvPr id="2" name="Text Placeholder 1"/>
+          <p:cNvSpPr>
+            <a:spLocks noGrp="1"/>
+          </p:cNvSpPr>
+          <p:nvPr>
+            <p:ph type="body" idx="10" sz="quarter"/>
+          </p:nvPr>
+        </p:nvSpPr>
+        <p:spPr/>
+        <p:txBody>
+          <a:bodyPr wrap="square"/>
+          <a:lstStyle/>
+          <a:p>
+            <a:pPr algn="ctr"/>
+            <a:r>
+              <a:rPr sz="1700" b="1">
+                <a:solidFill>
+                  <a:srgbClr val="CD2D37"/>
+                </a:solidFill>
+                <a:latin typeface="Arial"/>
+              </a:rPr>
+              <a:t>DEMO EN VIVO</a:t>
+            </a:r>
+          </a:p>
+          <a:p>
+            <a:pPr algn="ctr"/>
+            <a:r>
+              <a:t>Verificación — smoke-test del entorno</a:t>
+            </a:r>
+          </a:p>
+          <a:p>
+            <a:pPr algn="ctr"/>
+            <a:r>
+              <a:rPr sz="1400">
+                <a:solidFill>
+                  <a:srgbClr val="9AA3B5"/>
+                </a:solidFill>
+                <a:latin typeface="Arial"/>
+              </a:rPr>
+              <a:t>bloque3_setup/demo_ecosystem_setup.ipynb</a:t>
+            </a:r>
+          </a:p>
+        </p:txBody>
+      </p:sp>
+      <p:sp>
+        <p:nvSpPr>
+          <p:cNvPr id="3" name="TextBox 2"/>
+          <p:cNvSpPr txBox="1"/>
+          <p:nvPr/>
+        </p:nvSpPr>
+        <p:spPr>
+          <a:xfrm>
+            <a:off x="2505456" y="3657600"/>
+            <a:ext cx="7168896" cy="2560320"/>
+          </a:xfrm>
+          <a:prstGeom prst="rect">
+            <a:avLst/>
+          </a:prstGeom>
+          <a:noFill/>
+        </p:spPr>
+        <p:txBody>
+          <a:bodyPr wrap="square">
+            <a:spAutoFit/>
+          </a:bodyPr>
+          <a:lstStyle/>
+          <a:p>
+            <a:r>
+              <a:rPr sz="1600">
+                <a:solidFill>
+                  <a:srgbClr val="D6DAE2"/>
+                </a:solidFill>
+                <a:latin typeface="Arial"/>
+              </a:rPr>
+              <a:t>1.  Abrir demo_ecosystem_setup.ipynb</a:t>
+            </a:r>
+          </a:p>
+          <a:p>
+            <a:r>
+              <a:rPr sz="1600">
+                <a:solidFill>
+                  <a:srgbClr val="D6DAE2"/>
+                </a:solidFill>
+                <a:latin typeface="Arial"/>
+              </a:rPr>
+              <a:t>2.  1. Dependencias Python — confirmar import de cada librería</a:t>
+            </a:r>
+          </a:p>
+          <a:p>
+            <a:r>
+              <a:rPr sz="1600">
+                <a:solidFill>
+                  <a:srgbClr val="D6DAE2"/>
+                </a:solidFill>
+                <a:latin typeface="Arial"/>
+              </a:rPr>
+              <a:t>3.  2. Modelos Ollama — qwen3-embedding y qwen2.5:14b responden</a:t>
+            </a:r>
+          </a:p>
+          <a:p>
+            <a:r>
+              <a:rPr sz="1600">
+                <a:solidFill>
+                  <a:srgbClr val="D6DAE2"/>
+                </a:solidFill>
+                <a:latin typeface="Arial"/>
+              </a:rPr>
+              <a:t>4.  3. GPU — detectada si existe, CPU si no</a:t>
+            </a:r>
+          </a:p>
+          <a:p>
+            <a:r>
+              <a:rPr sz="1600">
+                <a:solidFill>
+                  <a:srgbClr val="D6DAE2"/>
+                </a:solidFill>
+                <a:latin typeface="Arial"/>
+              </a:rPr>
+              <a:t>5.  4. Smoke-test ChromaDB — guardar y consultar embeddings sintéticos</a:t>
+            </a:r>
+          </a:p>
+        </p:txBody>
+      </p:sp>
+    </p:spTree>
+  </p:cSld>
+  <p:clrMapOvr>
+    <a:masterClrMapping/>
+  </p:clrMapOvr>
+</p:sld>
+</file>
+
+<file path=ppt/slides/slide13.xml><?xml version="1.0" encoding="utf-8"?>
+<p:sld xmlns:a="http://schemas.openxmlformats.org/drawingml/2006/main" xmlns:p="http://schemas.openxmlformats.org/presentationml/2006/main" xmlns:r="http://schemas.openxmlformats.org/officeDocument/2006/relationships">
+  <p:cSld>
+    <p:spTree>
+      <p:nvGrpSpPr>
+        <p:cNvPr id="1" name=""/>
+        <p:cNvGrpSpPr/>
+        <p:nvPr/>
+      </p:nvGrpSpPr>
+      <p:grpSpPr/>
+      <p:sp>
+        <p:nvSpPr>
+          <p:cNvPr id="2" name="Text Placeholder 1"/>
+          <p:cNvSpPr>
+            <a:spLocks noGrp="1"/>
+          </p:cNvSpPr>
+          <p:nvPr>
+            <p:ph type="body" idx="13" sz="quarter"/>
+          </p:nvPr>
+        </p:nvSpPr>
+        <p:spPr/>
+        <p:txBody>
+          <a:bodyPr wrap="square"/>
+          <a:lstStyle/>
+          <a:p>
+            <a:r>
+              <a:t>Preguntas frecuentes y respuestas honestas</a:t>
+            </a:r>
+          </a:p>
+        </p:txBody>
+      </p:sp>
+      <p:sp>
+        <p:nvSpPr>
+          <p:cNvPr id="3" name="Text Placeholder 2"/>
+          <p:cNvSpPr>
+            <a:spLocks noGrp="1"/>
+          </p:cNvSpPr>
+          <p:nvPr>
+            <p:ph type="body" idx="16" sz="quarter"/>
+          </p:nvPr>
+        </p:nvSpPr>
+        <p:spPr>
+          <a:xfrm>
+            <a:off x="1073427" y="2214736"/>
+            <a:ext cx="10084904" cy="3370138"/>
           </a:xfrm>
         </p:spPr>
         <p:txBody>
@@ -5456,17 +6044,12 @@
           </a:p>
           <a:p>
             <a:r>
-              <a:t>¿Qué pasa si no tengo GPU? → CPU funciona, solo con muestras pequeñas en demo</a:t>
+              <a:t>¿Qué pasa si no tengo GPU? → CPU funciona para EDA y muestras pequeñas</a:t>
             </a:r>
           </a:p>
           <a:p>
             <a:r>
               <a:t>¿Puedo correr esto en Colab? → Técnicamente sí, pero no con datos reales</a:t>
-            </a:r>
-          </a:p>
-          <a:p>
-            <a:r>
-              <a:t>¿Cuánto tiempo tarda el pipeline completo? → 1-2 días con GPU para el dataset grande</a:t>
             </a:r>
           </a:p>
           <a:p>
@@ -5511,7 +6094,7 @@
           <a:p>
             <a:pPr algn="ctr"/>
             <a:r>
-              <a:rPr sz="1300" b="1">
+              <a:rPr sz="1700" b="1">
                 <a:solidFill>
                   <a:srgbClr val="CD2D37"/>
                 </a:solidFill>
@@ -5523,7 +6106,7 @@
           <a:p>
             <a:pPr algn="ctr"/>
             <a:r>
-              <a:t>El entorno</a:t>
+              <a:t>Gestión de dependencias con uv</a:t>
             </a:r>
           </a:p>
           <a:p>
@@ -5535,7 +6118,7 @@
                 </a:solidFill>
                 <a:latin typeface="Arial"/>
               </a:rPr>
-              <a:t>uv + Ollama + Jupyter — sin magia, sin Docker</a:t>
+              <a:t>Sin magia, sin Docker</a:t>
             </a:r>
           </a:p>
         </p:txBody>
@@ -5589,7 +6172,12 @@
             <p:ph type="body" idx="16" sz="quarter"/>
           </p:nvPr>
         </p:nvSpPr>
-        <p:spPr/>
+        <p:spPr>
+          <a:xfrm>
+            <a:off x="1073427" y="1711816"/>
+            <a:ext cx="10084904" cy="3873058"/>
+          </a:xfrm>
+        </p:spPr>
         <p:txBody>
           <a:bodyPr wrap="square"/>
           <a:lstStyle/>
@@ -5610,7 +6198,7 @@
           </a:p>
           <a:p>
             <a:r>
-              <a:t>Reproducible en cualquier máquina con Python 3.10+ sin configuración extra</a:t>
+              <a:t>Reproducible en cualquier máquina con Python 3.12+ sin configuración extra</a:t>
             </a:r>
           </a:p>
           <a:p>
@@ -5659,7 +6247,7 @@
           <a:lstStyle/>
           <a:p>
             <a:r>
-              <a:t>Setup completo — 4 comandos</a:t>
+              <a:t>Instalación paso a paso</a:t>
             </a:r>
           </a:p>
         </p:txBody>
@@ -5689,7 +6277,7 @@
         </p:nvSpPr>
         <p:spPr>
           <a:xfrm>
-            <a:off x="1051560" y="2194560"/>
+            <a:off x="1051560" y="1828800"/>
             <a:ext cx="10058400" cy="502920"/>
           </a:xfrm>
           <a:prstGeom prst="rect">
@@ -5724,8 +6312,8 @@
         </p:nvSpPr>
         <p:spPr>
           <a:xfrm>
-            <a:off x="1005840" y="2743200"/>
-            <a:ext cx="10149840" cy="3063240"/>
+            <a:off x="1005840" y="2377440"/>
+            <a:ext cx="10149840" cy="3429000"/>
           </a:xfrm>
           <a:prstGeom prst="rect">
             <a:avLst/>
@@ -5767,8 +6355,8 @@
         </p:nvSpPr>
         <p:spPr>
           <a:xfrm>
-            <a:off x="1188720" y="2880360"/>
-            <a:ext cx="9784080" cy="2788920"/>
+            <a:off x="1188720" y="2514600"/>
+            <a:ext cx="9784080" cy="3154680"/>
           </a:xfrm>
           <a:prstGeom prst="rect">
             <a:avLst/>
@@ -5792,10 +6380,7 @@
 git clone &lt;repo-url&gt; &amp;&amp; cd csbc26
 # 2. Instalar dependencias Python
 uv sync
-# 3. Descargar modelos Ollama (hacerlo antes de la clase)
-ollama pull qwen3-embedding
-ollama pull qwen2.5:14b
-# 4. Arrancar Jupyter
+# 3. Arrancar Jupyter dentro del entorno gestionado por uv
 uv run jupyter notebook</a:t>
             </a:r>
           </a:p>
@@ -5831,7 +6416,7 @@
                 </a:solidFill>
                 <a:latin typeface="Arial"/>
               </a:rPr>
-              <a:t>ℹ  Los modelos pesan ~9GB en total. Descargarlos la noche antes, no en vivo.</a:t>
+              <a:t>ℹ  Sin git (aulas con solo navegador): descargar el repo como ZIP desde GitHub.</a:t>
             </a:r>
           </a:p>
         </p:txBody>
@@ -5861,7 +6446,7 @@
             <a:spLocks noGrp="1"/>
           </p:cNvSpPr>
           <p:nvPr>
-            <p:ph type="body" idx="13" sz="quarter"/>
+            <p:ph type="body" idx="10" sz="quarter"/>
           </p:nvPr>
         </p:nvSpPr>
         <p:spPr/>
@@ -5869,251 +6454,33 @@
           <a:bodyPr wrap="square"/>
           <a:lstStyle/>
           <a:p>
-            <a:r>
-              <a:t>Requisitos de hardware — no hace falta potencia</a:t>
-            </a:r>
-          </a:p>
-        </p:txBody>
-      </p:sp>
-      <p:sp>
-        <p:nvSpPr>
-          <p:cNvPr id="3" name="Text Placeholder 2"/>
-          <p:cNvSpPr>
-            <a:spLocks noGrp="1"/>
-          </p:cNvSpPr>
-          <p:nvPr>
-            <p:ph type="body" idx="16" sz="quarter"/>
-          </p:nvPr>
-        </p:nvSpPr>
-        <p:spPr/>
-        <p:txBody>
-          <a:bodyPr/>
-          <a:lstStyle/>
-          <a:p/>
-        </p:txBody>
-      </p:sp>
-      <p:sp>
-        <p:nvSpPr>
-          <p:cNvPr id="4" name="TextBox 3"/>
-          <p:cNvSpPr txBox="1"/>
-          <p:nvPr/>
-        </p:nvSpPr>
-        <p:spPr>
-          <a:xfrm>
-            <a:off x="1051560" y="2194560"/>
-            <a:ext cx="4846320" cy="411480"/>
-          </a:xfrm>
-          <a:prstGeom prst="rect">
-            <a:avLst/>
-          </a:prstGeom>
-          <a:noFill/>
-        </p:spPr>
-        <p:txBody>
-          <a:bodyPr wrap="square">
-            <a:spAutoFit/>
-          </a:bodyPr>
-          <a:lstStyle/>
-          <a:p>
-            <a:pPr algn="l"/>
-            <a:r>
-              <a:rPr sz="1600" b="1">
+            <a:pPr algn="ctr"/>
+            <a:r>
+              <a:rPr sz="1700" b="1">
                 <a:solidFill>
                   <a:srgbClr val="CD2D37"/>
                 </a:solidFill>
                 <a:latin typeface="Arial"/>
               </a:rPr>
-              <a:t>Mínimo (análisis pandas/networkx)</a:t>
-            </a:r>
-          </a:p>
-        </p:txBody>
-      </p:sp>
-      <p:sp>
-        <p:nvSpPr>
-          <p:cNvPr id="5" name="TextBox 4"/>
-          <p:cNvSpPr txBox="1"/>
-          <p:nvPr/>
-        </p:nvSpPr>
-        <p:spPr>
-          <a:xfrm>
-            <a:off x="1051560" y="2651760"/>
-            <a:ext cx="4846320" cy="3337560"/>
-          </a:xfrm>
-          <a:prstGeom prst="rect">
-            <a:avLst/>
-          </a:prstGeom>
-          <a:noFill/>
-        </p:spPr>
-        <p:txBody>
-          <a:bodyPr wrap="square">
-            <a:spAutoFit/>
-          </a:bodyPr>
-          <a:lstStyle/>
-          <a:p>
+              <a:t>SECCIÓN 2</a:t>
+            </a:r>
+          </a:p>
+          <a:p>
+            <a:pPr algn="ctr"/>
+            <a:r>
+              <a:t>Ollama</a:t>
+            </a:r>
+          </a:p>
+          <a:p>
+            <a:pPr algn="ctr"/>
             <a:r>
               <a:rPr sz="1600">
                 <a:solidFill>
-                  <a:srgbClr val="465461"/>
+                  <a:srgbClr val="D6DAE2"/>
                 </a:solidFill>
                 <a:latin typeface="Arial"/>
               </a:rPr>
-              <a:t>▸  8GB RAM</a:t>
-            </a:r>
-          </a:p>
-          <a:p>
-            <a:r>
-              <a:rPr sz="1600">
-                <a:solidFill>
-                  <a:srgbClr val="465461"/>
-                </a:solidFill>
-                <a:latin typeface="Arial"/>
-              </a:rPr>
-              <a:t>▸  Cualquier CPU moderna</a:t>
-            </a:r>
-          </a:p>
-          <a:p>
-            <a:r>
-              <a:rPr sz="1600">
-                <a:solidFill>
-                  <a:srgbClr val="465461"/>
-                </a:solidFill>
-                <a:latin typeface="Arial"/>
-              </a:rPr>
-              <a:t>▸  10GB disco libre para datos y modelos</a:t>
-            </a:r>
-          </a:p>
-          <a:p>
-            <a:r>
-              <a:rPr sz="1600">
-                <a:solidFill>
-                  <a:srgbClr val="465461"/>
-                </a:solidFill>
-                <a:latin typeface="Arial"/>
-              </a:rPr>
-              <a:t>▸  Python 3.10+</a:t>
-            </a:r>
-          </a:p>
-          <a:p>
-            <a:r>
-              <a:rPr sz="1600">
-                <a:solidFill>
-                  <a:srgbClr val="465461"/>
-                </a:solidFill>
-                <a:latin typeface="Arial"/>
-              </a:rPr>
-              <a:t>▸  EDA, grafos, text mining: fluidos</a:t>
-            </a:r>
-          </a:p>
-        </p:txBody>
-      </p:sp>
-      <p:sp>
-        <p:nvSpPr>
-          <p:cNvPr id="6" name="TextBox 5"/>
-          <p:cNvSpPr txBox="1"/>
-          <p:nvPr/>
-        </p:nvSpPr>
-        <p:spPr>
-          <a:xfrm>
-            <a:off x="6217920" y="2194560"/>
-            <a:ext cx="4846320" cy="411480"/>
-          </a:xfrm>
-          <a:prstGeom prst="rect">
-            <a:avLst/>
-          </a:prstGeom>
-          <a:noFill/>
-        </p:spPr>
-        <p:txBody>
-          <a:bodyPr wrap="square">
-            <a:spAutoFit/>
-          </a:bodyPr>
-          <a:lstStyle/>
-          <a:p>
-            <a:pPr algn="l"/>
-            <a:r>
-              <a:rPr sz="1600" b="1">
-                <a:solidFill>
-                  <a:srgbClr val="CD2D37"/>
-                </a:solidFill>
-                <a:latin typeface="Arial"/>
-              </a:rPr>
-              <a:t>Recomendado (embeddings + LLM)</a:t>
-            </a:r>
-          </a:p>
-        </p:txBody>
-      </p:sp>
-      <p:sp>
-        <p:nvSpPr>
-          <p:cNvPr id="7" name="TextBox 6"/>
-          <p:cNvSpPr txBox="1"/>
-          <p:nvPr/>
-        </p:nvSpPr>
-        <p:spPr>
-          <a:xfrm>
-            <a:off x="6217920" y="2651760"/>
-            <a:ext cx="4846320" cy="3337560"/>
-          </a:xfrm>
-          <a:prstGeom prst="rect">
-            <a:avLst/>
-          </a:prstGeom>
-          <a:noFill/>
-        </p:spPr>
-        <p:txBody>
-          <a:bodyPr wrap="square">
-            <a:spAutoFit/>
-          </a:bodyPr>
-          <a:lstStyle/>
-          <a:p>
-            <a:r>
-              <a:rPr sz="1600">
-                <a:solidFill>
-                  <a:srgbClr val="465461"/>
-                </a:solidFill>
-                <a:latin typeface="Arial"/>
-              </a:rPr>
-              <a:t>▸  16GB RAM para qwen2.5:14b Q4</a:t>
-            </a:r>
-          </a:p>
-          <a:p>
-            <a:r>
-              <a:rPr sz="1600">
-                <a:solidFill>
-                  <a:srgbClr val="465461"/>
-                </a:solidFill>
-                <a:latin typeface="Arial"/>
-              </a:rPr>
-              <a:t>▸  GPU opcional (acelera embeddings ×10)</a:t>
-            </a:r>
-          </a:p>
-          <a:p>
-            <a:r>
-              <a:rPr sz="1600">
-                <a:solidFill>
-                  <a:srgbClr val="465461"/>
-                </a:solidFill>
-                <a:latin typeface="Arial"/>
-              </a:rPr>
-              <a:t>▸  25GB disco para todos los modelos</a:t>
-            </a:r>
-          </a:p>
-          <a:p>
-            <a:r>
-              <a:rPr sz="1600">
-                <a:solidFill>
-                  <a:srgbClr val="465461"/>
-                </a:solidFill>
-                <a:latin typeface="Arial"/>
-              </a:rPr>
-              <a:t>▸  Embeddings en CPU: lentos pero funcionales</a:t>
-            </a:r>
-          </a:p>
-          <a:p>
-            <a:r>
-              <a:rPr sz="1600">
-                <a:solidFill>
-                  <a:srgbClr val="465461"/>
-                </a:solidFill>
-                <a:latin typeface="Arial"/>
-              </a:rPr>
-              <a:t>▸  Demo con muestra pequeña: instantánea en cualquier hardware</a:t>
+              <a:t>El LLM que corre en tu máquina</a:t>
             </a:r>
           </a:p>
         </p:txBody>
@@ -6152,7 +6519,7 @@
           <a:lstStyle/>
           <a:p>
             <a:r>
-              <a:t>La estrategia de la demo en vivo</a:t>
+              <a:t>¿Qué es Ollama?</a:t>
             </a:r>
           </a:p>
         </p:txBody>
@@ -6169,8 +6536,8 @@
         </p:nvSpPr>
         <p:spPr>
           <a:xfrm>
-            <a:off x="1073427" y="2077576"/>
-            <a:ext cx="10084904" cy="3507298"/>
+            <a:off x="1073427" y="1711816"/>
+            <a:ext cx="10084904" cy="3873058"/>
           </a:xfrm>
         </p:spPr>
         <p:txBody>
@@ -6178,27 +6545,27 @@
           <a:lstStyle/>
           <a:p>
             <a:r>
-              <a:t>Los embeddings del dataset completo están precomputados — no esperamos en clase</a:t>
-            </a:r>
-          </a:p>
-          <a:p>
-            <a:r>
-              <a:t>Mostramos el código que los generó y lo ejecutamos sobre una muestra de 100 usuarios</a:t>
-            </a:r>
-          </a:p>
-          <a:p>
-            <a:r>
-              <a:t>Los modelos Ollama ya están descargados — mostramos el pull pero lo cortamos</a:t>
-            </a:r>
-          </a:p>
-          <a:p>
-            <a:r>
-              <a:t>Esto es el mismo truco de los videotutoriales: el proceso es real, la espera es editada</a:t>
-            </a:r>
-          </a:p>
-          <a:p>
-            <a:r>
-              <a:t>El objetivo no es la velocidad — es que el pipeline completo sea visible y reproducible</a:t>
+              <a:t>Runtime que corre LLMs directamente en tu máquina, sin API externa</a:t>
+            </a:r>
+          </a:p>
+          <a:p>
+            <a:r>
+              <a:t>Descarga el modelo cuantizado una vez, lo carga en memoria</a:t>
+            </a:r>
+          </a:p>
+          <a:p>
+            <a:r>
+              <a:t>Expone un servidor local en http://localhost:11434</a:t>
+            </a:r>
+          </a:p>
+          <a:p>
+            <a:r>
+              <a:t>Cualquier programa Python le hace peticiones, igual que a una API en la nube</a:t>
+            </a:r>
+          </a:p>
+          <a:p>
+            <a:r>
+              <a:t>Razón de ser del curso: un leak sensible no puede pasar por infraestructura de terceros</a:t>
             </a:r>
           </a:p>
         </p:txBody>
@@ -6228,7 +6595,7 @@
             <a:spLocks noGrp="1"/>
           </p:cNvSpPr>
           <p:nvPr>
-            <p:ph type="body" idx="10" sz="quarter"/>
+            <p:ph type="body" idx="13" sz="quarter"/>
           </p:nvPr>
         </p:nvSpPr>
         <p:spPr/>
@@ -6236,33 +6603,301 @@
           <a:bodyPr wrap="square"/>
           <a:lstStyle/>
           <a:p>
-            <a:pPr algn="ctr"/>
-            <a:r>
-              <a:rPr sz="1300" b="1">
+            <a:r>
+              <a:t>Los dos modelos que usamos</a:t>
+            </a:r>
+          </a:p>
+        </p:txBody>
+      </p:sp>
+      <p:sp>
+        <p:nvSpPr>
+          <p:cNvPr id="3" name="Text Placeholder 2"/>
+          <p:cNvSpPr>
+            <a:spLocks noGrp="1"/>
+          </p:cNvSpPr>
+          <p:nvPr>
+            <p:ph type="body" idx="16" sz="quarter"/>
+          </p:nvPr>
+        </p:nvSpPr>
+        <p:spPr/>
+        <p:txBody>
+          <a:bodyPr/>
+          <a:lstStyle/>
+          <a:p/>
+        </p:txBody>
+      </p:sp>
+      <p:sp>
+        <p:nvSpPr>
+          <p:cNvPr id="4" name="TextBox 3"/>
+          <p:cNvSpPr txBox="1"/>
+          <p:nvPr/>
+        </p:nvSpPr>
+        <p:spPr>
+          <a:xfrm>
+            <a:off x="1051560" y="1828800"/>
+            <a:ext cx="4846320" cy="411480"/>
+          </a:xfrm>
+          <a:prstGeom prst="rect">
+            <a:avLst/>
+          </a:prstGeom>
+          <a:noFill/>
+        </p:spPr>
+        <p:txBody>
+          <a:bodyPr wrap="square">
+            <a:spAutoFit/>
+          </a:bodyPr>
+          <a:lstStyle/>
+          <a:p>
+            <a:pPr algn="l"/>
+            <a:r>
+              <a:rPr sz="1600" b="1">
                 <a:solidFill>
                   <a:srgbClr val="CD2D37"/>
                 </a:solidFill>
                 <a:latin typeface="Arial"/>
               </a:rPr>
-              <a:t>SECCIÓN 2</a:t>
-            </a:r>
-          </a:p>
-          <a:p>
-            <a:pPr algn="ctr"/>
-            <a:r>
-              <a:t>El pipeline completo</a:t>
-            </a:r>
-          </a:p>
-          <a:p>
-            <a:pPr algn="ctr"/>
+              <a:t>qwen3-embedding</a:t>
+            </a:r>
+          </a:p>
+        </p:txBody>
+      </p:sp>
+      <p:sp>
+        <p:nvSpPr>
+          <p:cNvPr id="5" name="TextBox 4"/>
+          <p:cNvSpPr txBox="1"/>
+          <p:nvPr/>
+        </p:nvSpPr>
+        <p:spPr>
+          <a:xfrm>
+            <a:off x="1051560" y="2286000"/>
+            <a:ext cx="4846320" cy="3703320"/>
+          </a:xfrm>
+          <a:prstGeom prst="rect">
+            <a:avLst/>
+          </a:prstGeom>
+          <a:noFill/>
+        </p:spPr>
+        <p:txBody>
+          <a:bodyPr wrap="square">
+            <a:spAutoFit/>
+          </a:bodyPr>
+          <a:lstStyle/>
+          <a:p>
             <a:r>
               <a:rPr sz="1600">
                 <a:solidFill>
-                  <a:srgbClr val="D6DAE2"/>
+                  <a:srgbClr val="CD2D37"/>
                 </a:solidFill>
                 <a:latin typeface="Arial"/>
               </a:rPr>
-              <a:t>De dump SQL a visualización — celda por celda</a:t>
+              <a:t>▸  </a:t>
+            </a:r>
+            <a:r>
+              <a:rPr sz="1600">
+                <a:solidFill>
+                  <a:srgbClr val="465461"/>
+                </a:solidFill>
+                <a:latin typeface="Arial"/>
+              </a:rPr>
+              <a:t>Genera embeddings: texto → vector numérico</a:t>
+            </a:r>
+          </a:p>
+          <a:p>
+            <a:r>
+              <a:rPr sz="1600">
+                <a:solidFill>
+                  <a:srgbClr val="CD2D37"/>
+                </a:solidFill>
+                <a:latin typeface="Arial"/>
+              </a:rPr>
+              <a:t>▸  </a:t>
+            </a:r>
+            <a:r>
+              <a:rPr sz="1600">
+                <a:solidFill>
+                  <a:srgbClr val="465461"/>
+                </a:solidFill>
+                <a:latin typeface="Arial"/>
+              </a:rPr>
+              <a:t>Clustering de usuarios por comportamiento</a:t>
+            </a:r>
+          </a:p>
+          <a:p>
+            <a:r>
+              <a:rPr sz="1600">
+                <a:solidFill>
+                  <a:srgbClr val="CD2D37"/>
+                </a:solidFill>
+                <a:latin typeface="Arial"/>
+              </a:rPr>
+              <a:t>▸  </a:t>
+            </a:r>
+            <a:r>
+              <a:rPr sz="1600">
+                <a:solidFill>
+                  <a:srgbClr val="465461"/>
+                </a:solidFill>
+                <a:latin typeface="Arial"/>
+              </a:rPr>
+              <a:t>Estilometría computacional</a:t>
+            </a:r>
+          </a:p>
+          <a:p>
+            <a:r>
+              <a:rPr sz="1600">
+                <a:solidFill>
+                  <a:srgbClr val="CD2D37"/>
+                </a:solidFill>
+                <a:latin typeface="Arial"/>
+              </a:rPr>
+              <a:t>▸  </a:t>
+            </a:r>
+            <a:r>
+              <a:rPr sz="1600">
+                <a:solidFill>
+                  <a:srgbClr val="465461"/>
+                </a:solidFill>
+                <a:latin typeface="Arial"/>
+              </a:rPr>
+              <a:t>Correlación cross-foro semántica (Bloque 2)</a:t>
+            </a:r>
+          </a:p>
+        </p:txBody>
+      </p:sp>
+      <p:sp>
+        <p:nvSpPr>
+          <p:cNvPr id="6" name="TextBox 5"/>
+          <p:cNvSpPr txBox="1"/>
+          <p:nvPr/>
+        </p:nvSpPr>
+        <p:spPr>
+          <a:xfrm>
+            <a:off x="6217920" y="1828800"/>
+            <a:ext cx="4846320" cy="411480"/>
+          </a:xfrm>
+          <a:prstGeom prst="rect">
+            <a:avLst/>
+          </a:prstGeom>
+          <a:noFill/>
+        </p:spPr>
+        <p:txBody>
+          <a:bodyPr wrap="square">
+            <a:spAutoFit/>
+          </a:bodyPr>
+          <a:lstStyle/>
+          <a:p>
+            <a:pPr algn="l"/>
+            <a:r>
+              <a:rPr sz="1600" b="1">
+                <a:solidFill>
+                  <a:srgbClr val="CD2D37"/>
+                </a:solidFill>
+                <a:latin typeface="Arial"/>
+              </a:rPr>
+              <a:t>qwen2.5:14b</a:t>
+            </a:r>
+          </a:p>
+        </p:txBody>
+      </p:sp>
+      <p:sp>
+        <p:nvSpPr>
+          <p:cNvPr id="7" name="TextBox 6"/>
+          <p:cNvSpPr txBox="1"/>
+          <p:nvPr/>
+        </p:nvSpPr>
+        <p:spPr>
+          <a:xfrm>
+            <a:off x="6217920" y="2286000"/>
+            <a:ext cx="4846320" cy="3703320"/>
+          </a:xfrm>
+          <a:prstGeom prst="rect">
+            <a:avLst/>
+          </a:prstGeom>
+          <a:noFill/>
+        </p:spPr>
+        <p:txBody>
+          <a:bodyPr wrap="square">
+            <a:spAutoFit/>
+          </a:bodyPr>
+          <a:lstStyle/>
+          <a:p>
+            <a:r>
+              <a:rPr sz="1600">
+                <a:solidFill>
+                  <a:srgbClr val="CD2D37"/>
+                </a:solidFill>
+                <a:latin typeface="Arial"/>
+              </a:rPr>
+              <a:t>▸  </a:t>
+            </a:r>
+            <a:r>
+              <a:rPr sz="1600">
+                <a:solidFill>
+                  <a:srgbClr val="465461"/>
+                </a:solidFill>
+                <a:latin typeface="Arial"/>
+              </a:rPr>
+              <a:t>LLM generativo, no embeddings</a:t>
+            </a:r>
+          </a:p>
+          <a:p>
+            <a:r>
+              <a:rPr sz="1600">
+                <a:solidFill>
+                  <a:srgbClr val="CD2D37"/>
+                </a:solidFill>
+                <a:latin typeface="Arial"/>
+              </a:rPr>
+              <a:t>▸  </a:t>
+            </a:r>
+            <a:r>
+              <a:rPr sz="1600">
+                <a:solidFill>
+                  <a:srgbClr val="465461"/>
+                </a:solidFill>
+                <a:latin typeface="Arial"/>
+              </a:rPr>
+              <a:t>NER en dominio específico</a:t>
+            </a:r>
+          </a:p>
+          <a:p>
+            <a:r>
+              <a:rPr sz="1600">
+                <a:solidFill>
+                  <a:srgbClr val="CD2D37"/>
+                </a:solidFill>
+                <a:latin typeface="Arial"/>
+              </a:rPr>
+              <a:t>▸  </a:t>
+            </a:r>
+            <a:r>
+              <a:rPr sz="1600">
+                <a:solidFill>
+                  <a:srgbClr val="465461"/>
+                </a:solidFill>
+                <a:latin typeface="Arial"/>
+              </a:rPr>
+              <a:t>Clasificación de posts</a:t>
+            </a:r>
+          </a:p>
+          <a:p>
+            <a:r>
+              <a:rPr sz="1600">
+                <a:solidFill>
+                  <a:srgbClr val="CD2D37"/>
+                </a:solidFill>
+                <a:latin typeface="Arial"/>
+              </a:rPr>
+              <a:t>▸  </a:t>
+            </a:r>
+            <a:r>
+              <a:rPr sz="1600">
+                <a:solidFill>
+                  <a:srgbClr val="465461"/>
+                </a:solidFill>
+                <a:latin typeface="Arial"/>
+              </a:rPr>
+              <a:t>Perfilado de roles (Bloque 2 y casos prácticos)</a:t>
             </a:r>
           </a:p>
         </p:txBody>
@@ -6301,7 +6936,7 @@
           <a:lstStyle/>
           <a:p>
             <a:r>
-              <a:t>Las 5 fases del pipeline</a:t>
+              <a:t>Cómo se usa desde Python y desde terminal</a:t>
             </a:r>
           </a:p>
         </p:txBody>
@@ -6316,38 +6951,33 @@
             <p:ph type="body" idx="16" sz="quarter"/>
           </p:nvPr>
         </p:nvSpPr>
-        <p:spPr/>
+        <p:spPr>
+          <a:xfrm>
+            <a:off x="1073427" y="2214736"/>
+            <a:ext cx="10084904" cy="3370138"/>
+          </a:xfrm>
+        </p:spPr>
         <p:txBody>
           <a:bodyPr wrap="square"/>
           <a:lstStyle/>
           <a:p>
             <a:r>
-              <a:t>1. Load: load_forum() con auto-detección de versión y encoding</a:t>
-            </a:r>
-          </a:p>
-          <a:p>
-            <a:r>
-              <a:t>2. Normalize: limpieza de usuarios, deduplicación, normalización de fechas a UTC</a:t>
-            </a:r>
-          </a:p>
-          <a:p>
-            <a:r>
-              <a:t>3. Analyze: estadística descriptiva, red de interacciones, análisis temporal</a:t>
-            </a:r>
-          </a:p>
-          <a:p>
-            <a:r>
-              <a:t>4. Embed: generación de embeddings por usuario (precomputados o muestra en vivo)</a:t>
-            </a:r>
-          </a:p>
-          <a:p>
-            <a:r>
-              <a:t>5. Visualize: grafos, heatmaps temporales, clusters UMAP con Plotly interactivo</a:t>
-            </a:r>
-          </a:p>
-          <a:p>
-            <a:r>
-              <a:t>Todo desde un único notebook, celda por celda, sin cambiar de herramienta</a:t>
+              <a:t>Librería ollama (instalada por uv sync): cliente delgado sobre el servidor local</a:t>
+            </a:r>
+          </a:p>
+          <a:p>
+            <a:r>
+              <a:t>ollama.chat(model=..., messages=...) y ollama.embed(model=..., input=...)</a:t>
+            </a:r>
+          </a:p>
+          <a:p>
+            <a:r>
+              <a:t>Usado en src/embeddings.py y src/utils.py a lo largo de todo el curso</a:t>
+            </a:r>
+          </a:p>
+          <a:p>
+            <a:r>
+              <a:t>Para limpieza puntual sin código: CLI llm + plugin de Ollama, pipeable desde terminal</a:t>
             </a:r>
           </a:p>
         </p:txBody>
@@ -6377,7 +7007,7 @@
             <a:spLocks noGrp="1"/>
           </p:cNvSpPr>
           <p:nvPr>
-            <p:ph type="body" idx="13" sz="quarter"/>
+            <p:ph type="body" idx="10" sz="quarter"/>
           </p:nvPr>
         </p:nvSpPr>
         <p:spPr/>
@@ -6385,59 +7015,33 @@
           <a:bodyPr wrap="square"/>
           <a:lstStyle/>
           <a:p>
-            <a:r>
-              <a:t>El dataset de demo — criterios de elección</a:t>
-            </a:r>
-          </a:p>
-        </p:txBody>
-      </p:sp>
-      <p:sp>
-        <p:nvSpPr>
-          <p:cNvPr id="3" name="Text Placeholder 2"/>
-          <p:cNvSpPr>
-            <a:spLocks noGrp="1"/>
-          </p:cNvSpPr>
-          <p:nvPr>
-            <p:ph type="body" idx="16" sz="quarter"/>
-          </p:nvPr>
-        </p:nvSpPr>
-        <p:spPr>
-          <a:xfrm>
-            <a:off x="1073427" y="2077576"/>
-            <a:ext cx="10084904" cy="3507298"/>
-          </a:xfrm>
-        </p:spPr>
-        <p:txBody>
-          <a:bodyPr wrap="square"/>
-          <a:lstStyle/>
-          <a:p>
-            <a:r>
-              <a:t>Pequeño y autocontenido — carga en segundos, sin problemas de RAM</a:t>
-            </a:r>
-          </a:p>
-          <a:p>
-            <a:r>
-              <a:t>Schema limpio: parser estándar sin variantes problemáticas</a:t>
-            </a:r>
-          </a:p>
-          <a:p>
-            <a:r>
-              <a:t>Suficientemente representativo: usuarios, posts, fechas, subforos</a:t>
-            </a:r>
-          </a:p>
-          <a:p>
-            <a:r>
-              <a:t>No requiere descarga de datos pesados para seguir la demo en clase</a:t>
-            </a:r>
-          </a:p>
-          <a:p>
-            <a:r>
-              <a:t>La estructura es idéntica a la de cualquier otro caso — el pipeline es generalizable</a:t>
-            </a:r>
-          </a:p>
-          <a:p>
-            <a:r>
-              <a:t>Los resultados son visibles en tiempo real sin esperar precomputo</a:t>
+            <a:pPr algn="ctr"/>
+            <a:r>
+              <a:rPr sz="1700" b="1">
+                <a:solidFill>
+                  <a:srgbClr val="CD2D37"/>
+                </a:solidFill>
+                <a:latin typeface="Arial"/>
+              </a:rPr>
+              <a:t>SECCIÓN 3</a:t>
+            </a:r>
+          </a:p>
+          <a:p>
+            <a:pPr algn="ctr"/>
+            <a:r>
+              <a:t>El stack de análisis</a:t>
+            </a:r>
+          </a:p>
+          <a:p>
+            <a:pPr algn="ctr"/>
+            <a:r>
+              <a:rPr sz="1600">
+                <a:solidFill>
+                  <a:srgbClr val="D6DAE2"/>
+                </a:solidFill>
+                <a:latin typeface="Arial"/>
+              </a:rPr>
+              <a:t>Qué instala uv sync y para qué sirve cada pieza</a:t>
             </a:r>
           </a:p>
         </p:txBody>

</xml_diff>

<commit_message>
docs(bloque3): reescribir demo_pipeline.ipynb y ampliar ppt con Ollama en profundidad
- demo_pipeline.ipynb pasa de pipeline de Carding Forums (no correspondía a
  este bloque) a una demo desglosada de Ollama: instalación/arquitectura,
  gestión de modelos (librería oficial y Hugging Face), generate/chat/embed
  paso a paso, y ajuste de generación (options, num_ctx). Ejecutado de punta
  a punta contra Ollama real, sin outputs simulados.
- csbc26_b3_setup.pptx: nuevas diapositivas sobre options/num_ctx, el bucle
  autorregresivo de generación, qué son los parámetros de un modelo
  (corrige la confusión parámetros=iteraciones) y cuantización a nivel de
  bits (Q4_K_M).
- nuevo generador assets/generate_generation_loop_diagram.py para el
  diagrama del bucle de generación.
</commit_message>
<xml_diff>
--- a/bloque3_setup/csbc26_b3_setup.pptx
+++ b/bloque3_setup/csbc26_b3_setup.pptx
@@ -31,6 +31,12 @@
     <p:sldId id="276" r:id="rId31"/>
     <p:sldId id="277" r:id="rId32"/>
     <p:sldId id="278" r:id="rId33"/>
+    <p:sldId id="279" r:id="rId34"/>
+    <p:sldId id="280" r:id="rId35"/>
+    <p:sldId id="281" r:id="rId36"/>
+    <p:sldId id="282" r:id="rId37"/>
+    <p:sldId id="283" r:id="rId38"/>
+    <p:sldId id="284" r:id="rId39"/>
   </p:sldIdLst>
   <p:sldSz cx="12192000" cy="6858000"/>
   <p:notesSz cx="6858000" cy="9144000"/>
@@ -979,12 +985,22 @@
           <a:lstStyle/>
           <a:p>
             <a:r>
-              <a:t>Tercera pieza, la más conceptual: qué es cada tipo de modelo</a:t>
-            </a:r>
-          </a:p>
-          <a:p>
-            <a:r>
-              <a:t>Esto les sirve para elegir modelos por su cuenta, no solo usar los del curso</a:t>
+              <a:t>Además de qué modelo usar, se puede ajustar CÓMO genera cada llamada</a:t>
+            </a:r>
+          </a:p>
+          <a:p>
+            <a:r>
+              <a:t>options es un diccionario que va en la misma llamada a chat/generate</a:t>
+            </a:r>
+          </a:p>
+          <a:p>
+            <a:r>
+              <a:t>No toca el modelo en disco, es por request</a:t>
+            </a:r>
+          </a:p>
+          <a:p>
+            <a:r>
+              <a:t>→ el que más importa si van a encadenar mensajes largos o RAG: num_ctx</a:t>
             </a:r>
           </a:p>
         </p:txBody>
@@ -1054,17 +1070,22 @@
           <a:lstStyle/>
           <a:p>
             <a:r>
-              <a:t>Embedding = huella numérica del significado, no el texto en sí</a:t>
-            </a:r>
-          </a:p>
-          <a:p>
-            <a:r>
-              <a:t>No entienden todavía cómo se calcula, y no hace falta</a:t>
-            </a:r>
-          </a:p>
-          <a:p>
-            <a:r>
-              <a:t>→ lo único importante: sirve para MEDIR parecido, no para escribir</a:t>
+              <a:t>Tabla de referencia, la que más van a usar es num_ctx y temperature</a:t>
+            </a:r>
+          </a:p>
+          <a:p>
+            <a:r>
+              <a:t>num_ctx: cuánto "recuerda" de la conversación o del documento que le pasás</a:t>
+            </a:r>
+          </a:p>
+          <a:p>
+            <a:r>
+              <a:t>temperature: cuánto se la juega el modelo al elegir la siguiente palabra</a:t>
+            </a:r>
+          </a:p>
+          <a:p>
+            <a:r>
+              <a:t>→ el resto se toca poco y casi siempre junto con estas dos</a:t>
             </a:r>
           </a:p>
         </p:txBody>
@@ -1134,17 +1155,22 @@
           <a:lstStyle/>
           <a:p>
             <a:r>
-              <a:t>Panel izquierdo: un ejemplo concreto, texto entra, vector sale</a:t>
-            </a:r>
-          </a:p>
-          <a:p>
-            <a:r>
-              <a:t>Panel derecho: por eso sirve para clustering — lo parecido queda junto</a:t>
-            </a:r>
-          </a:p>
-          <a:p>
-            <a:r>
-              <a:t>→ el post 'random' queda lejos de ambos grupos, ejemplo de outlier</a:t>
+              <a:t>El default de qwen2.5:14b es 4096 tokens — se ve con 'ollama ps' mientras corre</a:t>
+            </a:r>
+          </a:p>
+          <a:p>
+            <a:r>
+              <a:t>Si tu agente arrastra un historial largo o metés varios documentos de contexto (RAG), 4096 se queda corto y el modelo empieza a "olvidar" el principio de la conversación sin ningún error visible</a:t>
+            </a:r>
+          </a:p>
+          <a:p>
+            <a:r>
+              <a:t>Subirlo a 8192 o más soluciona eso, pero pide más VRAM — se ve reflejado en 'ollama ps' (SIZE sube junto con CONTEXT)</a:t>
+            </a:r>
+          </a:p>
+          <a:p>
+            <a:r>
+              <a:t>→ mi compañero que va a trabajar con LLM generativo (agentes, Bloque 4): este es el parámetro que más les va a importar</a:t>
             </a:r>
           </a:p>
         </p:txBody>
@@ -1214,17 +1240,12 @@
           <a:lstStyle/>
           <a:p>
             <a:r>
-              <a:t>Generativo = escribe. Embedding = mide. No son lo mismo ni intercambiables</a:t>
-            </a:r>
-          </a:p>
-          <a:p>
-            <a:r>
-              <a:t>qwen2.5:14b es generativo, qwen3-embedding no lo es</a:t>
-            </a:r>
-          </a:p>
-          <a:p>
-            <a:r>
-              <a:t>→ por eso el curso usa los dos, para tareas distintas</a:t>
+              <a:t>Tercera pieza, la más conceptual: qué es cada tipo de modelo</a:t>
+            </a:r>
+          </a:p>
+          <a:p>
+            <a:r>
+              <a:t>Esto les sirve para elegir modelos por su cuenta, no solo usar los del curso</a:t>
             </a:r>
           </a:p>
         </p:txBody>
@@ -1294,22 +1315,22 @@
           <a:lstStyle/>
           <a:p>
             <a:r>
-              <a:t>Mismo modelo, tres precisiones distintas, mira el tamaño</a:t>
-            </a:r>
-          </a:p>
-          <a:p>
-            <a:r>
-              <a:t>FP16: máxima precisión, 30GB. Q4: el que usamos, menos de 9GB</a:t>
-            </a:r>
-          </a:p>
-          <a:p>
-            <a:r>
-              <a:t>→ la pérdida de calidad es pequeña para lo que hacemos aquí</a:t>
-            </a:r>
-          </a:p>
-          <a:p>
-            <a:r>
-              <a:t>Por eso qwen2.5:14b Q4 cabe en un portátil normal</a:t>
+              <a:t>Embedding = huella numérica del significado, no el texto en sí</a:t>
+            </a:r>
+          </a:p>
+          <a:p>
+            <a:r>
+              <a:t>No entienden todavía cómo se calcula, y no hace falta</a:t>
+            </a:r>
+          </a:p>
+          <a:p>
+            <a:r>
+              <a:t>→ lo único importante: sirve para MEDIR parecido, no para escribir</a:t>
+            </a:r>
+          </a:p>
+          <a:p>
+            <a:r>
+              <a:t>Siempre el mismo tamaño de vector (4096), un post de una línea o de un párrafo entero</a:t>
             </a:r>
           </a:p>
         </p:txBody>
@@ -1379,22 +1400,17 @@
           <a:lstStyle/>
           <a:p>
             <a:r>
-              <a:t>La decisión no es "el modelo más grande posible"</a:t>
-            </a:r>
-          </a:p>
-          <a:p>
-            <a:r>
-              <a:t>Es equilibrio: ¿tu hardware aguanta? ¿de verdad necesitas ese tamaño?</a:t>
-            </a:r>
-          </a:p>
-          <a:p>
-            <a:r>
-              <a:t>→ en el curso ya elegimos ese equilibrio por ustedes (qwen2.5:14b Q4)</a:t>
-            </a:r>
-          </a:p>
-          <a:p>
-            <a:r>
-              <a:t>Para sus propios proyectos, el criterio es el mismo</a:t>
+              <a:t>Panel izquierdo: un ejemplo concreto, texto entra, vector sale</a:t>
+            </a:r>
+          </a:p>
+          <a:p>
+            <a:r>
+              <a:t>Panel derecho: por eso sirve para clustering — lo parecido queda junto</a:t>
+            </a:r>
+          </a:p>
+          <a:p>
+            <a:r>
+              <a:t>→ el post 'random' queda lejos de ambos grupos, ejemplo de outlier</a:t>
             </a:r>
           </a:p>
         </p:txBody>
@@ -1464,22 +1480,22 @@
           <a:lstStyle/>
           <a:p>
             <a:r>
-              <a:t>Hugging Face es el catálogo — miles de modelos, filtrar por formato GGUF</a:t>
-            </a:r>
-          </a:p>
-          <a:p>
-            <a:r>
-              <a:t>ollama pull hf.co/usuario/modelo trae el modelo directo, sin descargarlo a mano</a:t>
-            </a:r>
-          </a:p>
-          <a:p>
-            <a:r>
-              <a:t>→ AQUÍ puedo parar la presentación y navegar Hugging Face en vivo</a:t>
-            </a:r>
-          </a:p>
-          <a:p>
-            <a:r>
-              <a:t>Buscar un modelo que pida el aula y traerlo con este mismo comando</a:t>
+              <a:t>Generativo = escribe. Embedding = mide. No son lo mismo ni intercambiables</a:t>
+            </a:r>
+          </a:p>
+          <a:p>
+            <a:r>
+              <a:t>qwen2.5:14b es generativo, qwen3-embedding no lo es</a:t>
+            </a:r>
+          </a:p>
+          <a:p>
+            <a:r>
+              <a:t>→ por eso el curso usa los dos, para tareas distintas</a:t>
+            </a:r>
+          </a:p>
+          <a:p>
+            <a:r>
+              <a:t>Ojo con la idea de que genera 'de una', va palabra por palabra — siguiente slide lo muestra</a:t>
             </a:r>
           </a:p>
         </p:txBody>
@@ -1549,17 +1565,27 @@
           <a:lstStyle/>
           <a:p>
             <a:r>
-              <a:t>hf.co/&lt;repo&gt; funciona igual que el nombre de un modelo de la librería oficial</a:t>
-            </a:r>
-          </a:p>
-          <a:p>
-            <a:r>
-              <a:t>No hace falta descargar el .gguf a mano ni convertir nada</a:t>
-            </a:r>
-          </a:p>
-          <a:p>
-            <a:r>
-              <a:t>→ momento para parar y navegar Hugging Face en vivo si el aula lo pide</a:t>
+              <a:t>Esto ES lo que la gente suele imaginar como 'los pasos' del modelo</a:t>
+            </a:r>
+          </a:p>
+          <a:p>
+            <a:r>
+              <a:t>Pasada 1: 'El mar es' entra completo → sale 'vasto'</a:t>
+            </a:r>
+          </a:p>
+          <a:p>
+            <a:r>
+              <a:t>Pasada 2: 'El mar es vasto' entra completo (con la palabra nueva ya puesta) → sale 'y'</a:t>
+            </a:r>
+          </a:p>
+          <a:p>
+            <a:r>
+              <a:t>→ tantas pasadas completas como palabras genera, no una por parámetro</a:t>
+            </a:r>
+          </a:p>
+          <a:p>
+            <a:r>
+              <a:t>Esto es autorregresivo: la salida de un paso es parte de la entrada del siguiente</a:t>
             </a:r>
           </a:p>
         </p:txBody>
@@ -1714,12 +1740,27 @@
           <a:lstStyle/>
           <a:p>
             <a:r>
-              <a:t>Cuarta pieza: las librerías</a:t>
-            </a:r>
-          </a:p>
-          <a:p>
-            <a:r>
-              <a:t>No todas — solo las que no son de uso general</a:t>
+              <a:t>Confusión MUY habitual, vale la pena pararse acá</a:t>
+            </a:r>
+          </a:p>
+          <a:p>
+            <a:r>
+              <a:t>'14B parámetros' no significa '14 mil millones de pasos' — son 14 mil millones de números fijos, aprendidos una vez en el entrenamiento</a:t>
+            </a:r>
+          </a:p>
+          <a:p>
+            <a:r>
+              <a:t>→ pensarlo como el tamaño del cerebro (cuánto sabe, cuánta capacidad), no como cuánto tarda o cuántas veces itera</a:t>
+            </a:r>
+          </a:p>
+          <a:p>
+            <a:r>
+              <a:t>Lo iterativo de verdad es la diapositiva anterior: una pasada completa por TODO el modelo, por cada palabra generada</a:t>
+            </a:r>
+          </a:p>
+          <a:p>
+            <a:r>
+              <a:t>Más parámetros = más capacidad para representar matices, pero no más 'pasos' por generación</a:t>
             </a:r>
           </a:p>
         </p:txBody>
@@ -1789,17 +1830,22 @@
           <a:lstStyle/>
           <a:p>
             <a:r>
-              <a:t>pandas/matplotlib/sklearn ya los conocen, no están aquí</a:t>
-            </a:r>
-          </a:p>
-          <a:p>
-            <a:r>
-              <a:t>→ cada una resuelve un problema puntual del pipeline</a:t>
-            </a:r>
-          </a:p>
-          <a:p>
-            <a:r>
-              <a:t>umap-learn es la menos obvia, detenerse ahí</a:t>
+              <a:t>Mismo modelo, tres precisiones distintas, mira el tamaño</a:t>
+            </a:r>
+          </a:p>
+          <a:p>
+            <a:r>
+              <a:t>FP16: máxima precisión, 30GB. Q4: el que usamos, menos de 9GB</a:t>
+            </a:r>
+          </a:p>
+          <a:p>
+            <a:r>
+              <a:t>→ la pérdida de calidad es pequeña para lo que hacemos aquí</a:t>
+            </a:r>
+          </a:p>
+          <a:p>
+            <a:r>
+              <a:t>Por eso qwen2.5:14b Q4 cabe en un portátil normal</a:t>
             </a:r>
           </a:p>
         </p:txBody>
@@ -1869,22 +1915,22 @@
           <a:lstStyle/>
           <a:p>
             <a:r>
-              <a:t>Tranquilizar: no hace falta gama alta</a:t>
-            </a:r>
-          </a:p>
-          <a:p>
-            <a:r>
-              <a:t>8GB RAM + CPU moderna = suficiente para pandas/networkx</a:t>
-            </a:r>
-          </a:p>
-          <a:p>
-            <a:r>
-              <a:t>Derecha: solo si embeddings + LLM local</a:t>
-            </a:r>
-          </a:p>
-          <a:p>
-            <a:r>
-              <a:t>→ sin GPU funciona, más lento, sobre muestra es instantáneo</a:t>
+              <a:t>Ahora que ya vimos qué es un parámetro, cuantizar es más concreto: no se tocan CUÁNTOS parámetros hay, se toca CUÁNTA precisión tiene cada uno</a:t>
+            </a:r>
+          </a:p>
+          <a:p>
+            <a:r>
+              <a:t>FP16 = 16 bits por parámetro, Q4 = ~4 bits por parámetro → por eso el tamaño baja a una fracción</a:t>
+            </a:r>
+          </a:p>
+          <a:p>
+            <a:r>
+              <a:t>→ Q4_K_M: Q4 = 4 bits, K = agrupa en bloques y reparte bits de forma más inteligente, M = variante 'medium' del reparto (hay S y L también)</a:t>
+            </a:r>
+          </a:p>
+          <a:p>
+            <a:r>
+              <a:t>Esto se ve en detalle con datos reales en el notebook, sección de cuantización</a:t>
             </a:r>
           </a:p>
         </p:txBody>
@@ -1910,6 +1956,496 @@
 </file>
 
 <file path=ppt/notesSlides/notesSlide23.xml><?xml version="1.0" encoding="utf-8"?>
+<p:notes xmlns:a="http://schemas.openxmlformats.org/drawingml/2006/main" xmlns:p="http://schemas.openxmlformats.org/presentationml/2006/main" xmlns:r="http://schemas.openxmlformats.org/officeDocument/2006/relationships">
+  <p:cSld>
+    <p:spTree>
+      <p:nvGrpSpPr>
+        <p:cNvPr id="1" name=""/>
+        <p:cNvGrpSpPr/>
+        <p:nvPr/>
+      </p:nvGrpSpPr>
+      <p:grpSpPr>
+        <a:xfrm>
+          <a:off x="0" y="0"/>
+          <a:ext cx="0" cy="0"/>
+          <a:chOff x="0" y="0"/>
+          <a:chExt cx="0" cy="0"/>
+        </a:xfrm>
+      </p:grpSpPr>
+      <p:sp>
+        <p:nvSpPr>
+          <p:cNvPr id="2" name="Slide Image Placeholder 1"/>
+          <p:cNvSpPr>
+            <a:spLocks noGrp="1"/>
+          </p:cNvSpPr>
+          <p:nvPr>
+            <p:ph type="sldImg" idx="2"/>
+          </p:nvPr>
+        </p:nvSpPr>
+        <p:spPr/>
+      </p:sp>
+      <p:sp>
+        <p:nvSpPr>
+          <p:cNvPr id="3" name="Notes Placeholder 2"/>
+          <p:cNvSpPr>
+            <a:spLocks noGrp="1"/>
+          </p:cNvSpPr>
+          <p:nvPr>
+            <p:ph type="body" idx="3" sz="quarter"/>
+          </p:nvPr>
+        </p:nvSpPr>
+        <p:spPr/>
+        <p:txBody>
+          <a:bodyPr/>
+          <a:lstStyle/>
+          <a:p>
+            <a:r>
+              <a:t>La decisión no es "el modelo más grande posible"</a:t>
+            </a:r>
+          </a:p>
+          <a:p>
+            <a:r>
+              <a:t>Es equilibrio: ¿tu hardware aguanta? ¿de verdad necesitas ese tamaño?</a:t>
+            </a:r>
+          </a:p>
+          <a:p>
+            <a:r>
+              <a:t>→ en el curso ya elegimos ese equilibrio por ustedes (qwen2.5:14b Q4)</a:t>
+            </a:r>
+          </a:p>
+          <a:p>
+            <a:r>
+              <a:t>Para sus propios proyectos, el criterio es el mismo</a:t>
+            </a:r>
+          </a:p>
+        </p:txBody>
+      </p:sp>
+      <p:sp>
+        <p:nvSpPr>
+          <p:cNvPr id="4" name="Slide Number Placeholder 3"/>
+          <p:cNvSpPr>
+            <a:spLocks noGrp="1"/>
+          </p:cNvSpPr>
+          <p:nvPr>
+            <p:ph type="sldNum" idx="5" sz="quarter"/>
+          </p:nvPr>
+        </p:nvSpPr>
+        <p:spPr/>
+      </p:sp>
+    </p:spTree>
+  </p:cSld>
+  <p:clrMapOvr>
+    <a:masterClrMapping/>
+  </p:clrMapOvr>
+</p:notes>
+</file>
+
+<file path=ppt/notesSlides/notesSlide24.xml><?xml version="1.0" encoding="utf-8"?>
+<p:notes xmlns:a="http://schemas.openxmlformats.org/drawingml/2006/main" xmlns:p="http://schemas.openxmlformats.org/presentationml/2006/main" xmlns:r="http://schemas.openxmlformats.org/officeDocument/2006/relationships">
+  <p:cSld>
+    <p:spTree>
+      <p:nvGrpSpPr>
+        <p:cNvPr id="1" name=""/>
+        <p:cNvGrpSpPr/>
+        <p:nvPr/>
+      </p:nvGrpSpPr>
+      <p:grpSpPr>
+        <a:xfrm>
+          <a:off x="0" y="0"/>
+          <a:ext cx="0" cy="0"/>
+          <a:chOff x="0" y="0"/>
+          <a:chExt cx="0" cy="0"/>
+        </a:xfrm>
+      </p:grpSpPr>
+      <p:sp>
+        <p:nvSpPr>
+          <p:cNvPr id="2" name="Slide Image Placeholder 1"/>
+          <p:cNvSpPr>
+            <a:spLocks noGrp="1"/>
+          </p:cNvSpPr>
+          <p:nvPr>
+            <p:ph type="sldImg" idx="2"/>
+          </p:nvPr>
+        </p:nvSpPr>
+        <p:spPr/>
+      </p:sp>
+      <p:sp>
+        <p:nvSpPr>
+          <p:cNvPr id="3" name="Notes Placeholder 2"/>
+          <p:cNvSpPr>
+            <a:spLocks noGrp="1"/>
+          </p:cNvSpPr>
+          <p:nvPr>
+            <p:ph type="body" idx="3" sz="quarter"/>
+          </p:nvPr>
+        </p:nvSpPr>
+        <p:spPr/>
+        <p:txBody>
+          <a:bodyPr/>
+          <a:lstStyle/>
+          <a:p>
+            <a:r>
+              <a:t>Hugging Face es el catálogo — miles de modelos, filtrar por formato GGUF</a:t>
+            </a:r>
+          </a:p>
+          <a:p>
+            <a:r>
+              <a:t>ollama pull hf.co/usuario/modelo trae el modelo directo, sin descargarlo a mano</a:t>
+            </a:r>
+          </a:p>
+          <a:p>
+            <a:r>
+              <a:t>→ AQUÍ puedo parar la presentación y navegar Hugging Face en vivo</a:t>
+            </a:r>
+          </a:p>
+          <a:p>
+            <a:r>
+              <a:t>Buscar un modelo que pida el aula y traerlo con este mismo comando</a:t>
+            </a:r>
+          </a:p>
+        </p:txBody>
+      </p:sp>
+      <p:sp>
+        <p:nvSpPr>
+          <p:cNvPr id="4" name="Slide Number Placeholder 3"/>
+          <p:cNvSpPr>
+            <a:spLocks noGrp="1"/>
+          </p:cNvSpPr>
+          <p:nvPr>
+            <p:ph type="sldNum" idx="5" sz="quarter"/>
+          </p:nvPr>
+        </p:nvSpPr>
+        <p:spPr/>
+      </p:sp>
+    </p:spTree>
+  </p:cSld>
+  <p:clrMapOvr>
+    <a:masterClrMapping/>
+  </p:clrMapOvr>
+</p:notes>
+</file>
+
+<file path=ppt/notesSlides/notesSlide25.xml><?xml version="1.0" encoding="utf-8"?>
+<p:notes xmlns:a="http://schemas.openxmlformats.org/drawingml/2006/main" xmlns:p="http://schemas.openxmlformats.org/presentationml/2006/main" xmlns:r="http://schemas.openxmlformats.org/officeDocument/2006/relationships">
+  <p:cSld>
+    <p:spTree>
+      <p:nvGrpSpPr>
+        <p:cNvPr id="1" name=""/>
+        <p:cNvGrpSpPr/>
+        <p:nvPr/>
+      </p:nvGrpSpPr>
+      <p:grpSpPr>
+        <a:xfrm>
+          <a:off x="0" y="0"/>
+          <a:ext cx="0" cy="0"/>
+          <a:chOff x="0" y="0"/>
+          <a:chExt cx="0" cy="0"/>
+        </a:xfrm>
+      </p:grpSpPr>
+      <p:sp>
+        <p:nvSpPr>
+          <p:cNvPr id="2" name="Slide Image Placeholder 1"/>
+          <p:cNvSpPr>
+            <a:spLocks noGrp="1"/>
+          </p:cNvSpPr>
+          <p:nvPr>
+            <p:ph type="sldImg" idx="2"/>
+          </p:nvPr>
+        </p:nvSpPr>
+        <p:spPr/>
+      </p:sp>
+      <p:sp>
+        <p:nvSpPr>
+          <p:cNvPr id="3" name="Notes Placeholder 2"/>
+          <p:cNvSpPr>
+            <a:spLocks noGrp="1"/>
+          </p:cNvSpPr>
+          <p:nvPr>
+            <p:ph type="body" idx="3" sz="quarter"/>
+          </p:nvPr>
+        </p:nvSpPr>
+        <p:spPr/>
+        <p:txBody>
+          <a:bodyPr/>
+          <a:lstStyle/>
+          <a:p>
+            <a:r>
+              <a:t>hf.co/&lt;repo&gt; funciona igual que el nombre de un modelo de la librería oficial</a:t>
+            </a:r>
+          </a:p>
+          <a:p>
+            <a:r>
+              <a:t>No hace falta descargar el .gguf a mano ni convertir nada</a:t>
+            </a:r>
+          </a:p>
+          <a:p>
+            <a:r>
+              <a:t>→ momento para parar y navegar Hugging Face en vivo si el aula lo pide</a:t>
+            </a:r>
+          </a:p>
+        </p:txBody>
+      </p:sp>
+      <p:sp>
+        <p:nvSpPr>
+          <p:cNvPr id="4" name="Slide Number Placeholder 3"/>
+          <p:cNvSpPr>
+            <a:spLocks noGrp="1"/>
+          </p:cNvSpPr>
+          <p:nvPr>
+            <p:ph type="sldNum" idx="5" sz="quarter"/>
+          </p:nvPr>
+        </p:nvSpPr>
+        <p:spPr/>
+      </p:sp>
+    </p:spTree>
+  </p:cSld>
+  <p:clrMapOvr>
+    <a:masterClrMapping/>
+  </p:clrMapOvr>
+</p:notes>
+</file>
+
+<file path=ppt/notesSlides/notesSlide26.xml><?xml version="1.0" encoding="utf-8"?>
+<p:notes xmlns:a="http://schemas.openxmlformats.org/drawingml/2006/main" xmlns:p="http://schemas.openxmlformats.org/presentationml/2006/main" xmlns:r="http://schemas.openxmlformats.org/officeDocument/2006/relationships">
+  <p:cSld>
+    <p:spTree>
+      <p:nvGrpSpPr>
+        <p:cNvPr id="1" name=""/>
+        <p:cNvGrpSpPr/>
+        <p:nvPr/>
+      </p:nvGrpSpPr>
+      <p:grpSpPr>
+        <a:xfrm>
+          <a:off x="0" y="0"/>
+          <a:ext cx="0" cy="0"/>
+          <a:chOff x="0" y="0"/>
+          <a:chExt cx="0" cy="0"/>
+        </a:xfrm>
+      </p:grpSpPr>
+      <p:sp>
+        <p:nvSpPr>
+          <p:cNvPr id="2" name="Slide Image Placeholder 1"/>
+          <p:cNvSpPr>
+            <a:spLocks noGrp="1"/>
+          </p:cNvSpPr>
+          <p:nvPr>
+            <p:ph type="sldImg" idx="2"/>
+          </p:nvPr>
+        </p:nvSpPr>
+        <p:spPr/>
+      </p:sp>
+      <p:sp>
+        <p:nvSpPr>
+          <p:cNvPr id="3" name="Notes Placeholder 2"/>
+          <p:cNvSpPr>
+            <a:spLocks noGrp="1"/>
+          </p:cNvSpPr>
+          <p:nvPr>
+            <p:ph type="body" idx="3" sz="quarter"/>
+          </p:nvPr>
+        </p:nvSpPr>
+        <p:spPr/>
+        <p:txBody>
+          <a:bodyPr/>
+          <a:lstStyle/>
+          <a:p>
+            <a:r>
+              <a:t>Cuarta pieza: las librerías</a:t>
+            </a:r>
+          </a:p>
+          <a:p>
+            <a:r>
+              <a:t>No todas — solo las que no son de uso general</a:t>
+            </a:r>
+          </a:p>
+        </p:txBody>
+      </p:sp>
+      <p:sp>
+        <p:nvSpPr>
+          <p:cNvPr id="4" name="Slide Number Placeholder 3"/>
+          <p:cNvSpPr>
+            <a:spLocks noGrp="1"/>
+          </p:cNvSpPr>
+          <p:nvPr>
+            <p:ph type="sldNum" idx="5" sz="quarter"/>
+          </p:nvPr>
+        </p:nvSpPr>
+        <p:spPr/>
+      </p:sp>
+    </p:spTree>
+  </p:cSld>
+  <p:clrMapOvr>
+    <a:masterClrMapping/>
+  </p:clrMapOvr>
+</p:notes>
+</file>
+
+<file path=ppt/notesSlides/notesSlide27.xml><?xml version="1.0" encoding="utf-8"?>
+<p:notes xmlns:a="http://schemas.openxmlformats.org/drawingml/2006/main" xmlns:p="http://schemas.openxmlformats.org/presentationml/2006/main" xmlns:r="http://schemas.openxmlformats.org/officeDocument/2006/relationships">
+  <p:cSld>
+    <p:spTree>
+      <p:nvGrpSpPr>
+        <p:cNvPr id="1" name=""/>
+        <p:cNvGrpSpPr/>
+        <p:nvPr/>
+      </p:nvGrpSpPr>
+      <p:grpSpPr>
+        <a:xfrm>
+          <a:off x="0" y="0"/>
+          <a:ext cx="0" cy="0"/>
+          <a:chOff x="0" y="0"/>
+          <a:chExt cx="0" cy="0"/>
+        </a:xfrm>
+      </p:grpSpPr>
+      <p:sp>
+        <p:nvSpPr>
+          <p:cNvPr id="2" name="Slide Image Placeholder 1"/>
+          <p:cNvSpPr>
+            <a:spLocks noGrp="1"/>
+          </p:cNvSpPr>
+          <p:nvPr>
+            <p:ph type="sldImg" idx="2"/>
+          </p:nvPr>
+        </p:nvSpPr>
+        <p:spPr/>
+      </p:sp>
+      <p:sp>
+        <p:nvSpPr>
+          <p:cNvPr id="3" name="Notes Placeholder 2"/>
+          <p:cNvSpPr>
+            <a:spLocks noGrp="1"/>
+          </p:cNvSpPr>
+          <p:nvPr>
+            <p:ph type="body" idx="3" sz="quarter"/>
+          </p:nvPr>
+        </p:nvSpPr>
+        <p:spPr/>
+        <p:txBody>
+          <a:bodyPr/>
+          <a:lstStyle/>
+          <a:p>
+            <a:r>
+              <a:t>pandas/matplotlib/sklearn ya los conocen, no están aquí</a:t>
+            </a:r>
+          </a:p>
+          <a:p>
+            <a:r>
+              <a:t>→ cada una resuelve un problema puntual del pipeline</a:t>
+            </a:r>
+          </a:p>
+          <a:p>
+            <a:r>
+              <a:t>umap-learn es la menos obvia, detenerse ahí</a:t>
+            </a:r>
+          </a:p>
+        </p:txBody>
+      </p:sp>
+      <p:sp>
+        <p:nvSpPr>
+          <p:cNvPr id="4" name="Slide Number Placeholder 3"/>
+          <p:cNvSpPr>
+            <a:spLocks noGrp="1"/>
+          </p:cNvSpPr>
+          <p:nvPr>
+            <p:ph type="sldNum" idx="5" sz="quarter"/>
+          </p:nvPr>
+        </p:nvSpPr>
+        <p:spPr/>
+      </p:sp>
+    </p:spTree>
+  </p:cSld>
+  <p:clrMapOvr>
+    <a:masterClrMapping/>
+  </p:clrMapOvr>
+</p:notes>
+</file>
+
+<file path=ppt/notesSlides/notesSlide28.xml><?xml version="1.0" encoding="utf-8"?>
+<p:notes xmlns:a="http://schemas.openxmlformats.org/drawingml/2006/main" xmlns:p="http://schemas.openxmlformats.org/presentationml/2006/main" xmlns:r="http://schemas.openxmlformats.org/officeDocument/2006/relationships">
+  <p:cSld>
+    <p:spTree>
+      <p:nvGrpSpPr>
+        <p:cNvPr id="1" name=""/>
+        <p:cNvGrpSpPr/>
+        <p:nvPr/>
+      </p:nvGrpSpPr>
+      <p:grpSpPr>
+        <a:xfrm>
+          <a:off x="0" y="0"/>
+          <a:ext cx="0" cy="0"/>
+          <a:chOff x="0" y="0"/>
+          <a:chExt cx="0" cy="0"/>
+        </a:xfrm>
+      </p:grpSpPr>
+      <p:sp>
+        <p:nvSpPr>
+          <p:cNvPr id="2" name="Slide Image Placeholder 1"/>
+          <p:cNvSpPr>
+            <a:spLocks noGrp="1"/>
+          </p:cNvSpPr>
+          <p:nvPr>
+            <p:ph type="sldImg" idx="2"/>
+          </p:nvPr>
+        </p:nvSpPr>
+        <p:spPr/>
+      </p:sp>
+      <p:sp>
+        <p:nvSpPr>
+          <p:cNvPr id="3" name="Notes Placeholder 2"/>
+          <p:cNvSpPr>
+            <a:spLocks noGrp="1"/>
+          </p:cNvSpPr>
+          <p:nvPr>
+            <p:ph type="body" idx="3" sz="quarter"/>
+          </p:nvPr>
+        </p:nvSpPr>
+        <p:spPr/>
+        <p:txBody>
+          <a:bodyPr/>
+          <a:lstStyle/>
+          <a:p>
+            <a:r>
+              <a:t>Tranquilizar: no hace falta gama alta</a:t>
+            </a:r>
+          </a:p>
+          <a:p>
+            <a:r>
+              <a:t>8GB RAM + CPU moderna = suficiente para pandas/networkx</a:t>
+            </a:r>
+          </a:p>
+          <a:p>
+            <a:r>
+              <a:t>Derecha: solo si embeddings + LLM local</a:t>
+            </a:r>
+          </a:p>
+          <a:p>
+            <a:r>
+              <a:t>→ sin GPU funciona, más lento, sobre muestra es instantáneo</a:t>
+            </a:r>
+          </a:p>
+        </p:txBody>
+      </p:sp>
+      <p:sp>
+        <p:nvSpPr>
+          <p:cNvPr id="4" name="Slide Number Placeholder 3"/>
+          <p:cNvSpPr>
+            <a:spLocks noGrp="1"/>
+          </p:cNvSpPr>
+          <p:nvPr>
+            <p:ph type="sldNum" idx="5" sz="quarter"/>
+          </p:nvPr>
+        </p:nvSpPr>
+        <p:spPr/>
+      </p:sp>
+    </p:spTree>
+  </p:cSld>
+  <p:clrMapOvr>
+    <a:masterClrMapping/>
+  </p:clrMapOvr>
+</p:notes>
+</file>
+
+<file path=ppt/notesSlides/notesSlide29.xml><?xml version="1.0" encoding="utf-8"?>
 <p:notes xmlns:a="http://schemas.openxmlformats.org/drawingml/2006/main" xmlns:p="http://schemas.openxmlformats.org/presentationml/2006/main" xmlns:r="http://schemas.openxmlformats.org/officeDocument/2006/relationships">
   <p:cSld>
     <p:spTree>
@@ -6635,7 +7171,7 @@
             <a:spLocks noGrp="1"/>
           </p:cNvSpPr>
           <p:nvPr>
-            <p:ph type="body" idx="10" sz="quarter"/>
+            <p:ph type="body" idx="13" sz="quarter"/>
           </p:nvPr>
         </p:nvSpPr>
         <p:spPr/>
@@ -6643,33 +7179,44 @@
           <a:bodyPr wrap="square"/>
           <a:lstStyle/>
           <a:p>
-            <a:pPr algn="ctr"/>
-            <a:r>
-              <a:rPr sz="1700" b="1">
-                <a:solidFill>
-                  <a:srgbClr val="CD2D37"/>
-                </a:solidFill>
-                <a:latin typeface="Arial"/>
-              </a:rPr>
-              <a:t>SECCIÓN 3</a:t>
-            </a:r>
-          </a:p>
-          <a:p>
-            <a:pPr algn="ctr"/>
-            <a:r>
-              <a:t>Entendiendo los modelos</a:t>
-            </a:r>
-          </a:p>
-          <a:p>
-            <a:pPr algn="ctr"/>
-            <a:r>
-              <a:rPr sz="1600">
-                <a:solidFill>
-                  <a:srgbClr val="D6DAE2"/>
-                </a:solidFill>
-                <a:latin typeface="Arial"/>
-              </a:rPr>
-              <a:t>Embeddings, generativos y cuantización</a:t>
+            <a:r>
+              <a:t>Ajustar el modelo: el diccionario options</a:t>
+            </a:r>
+          </a:p>
+        </p:txBody>
+      </p:sp>
+      <p:sp>
+        <p:nvSpPr>
+          <p:cNvPr id="3" name="Text Placeholder 2"/>
+          <p:cNvSpPr>
+            <a:spLocks noGrp="1"/>
+          </p:cNvSpPr>
+          <p:nvPr>
+            <p:ph type="body" idx="16" sz="quarter"/>
+          </p:nvPr>
+        </p:nvSpPr>
+        <p:spPr>
+          <a:xfrm>
+            <a:off x="1073427" y="2214736"/>
+            <a:ext cx="10084904" cy="3370138"/>
+          </a:xfrm>
+        </p:spPr>
+        <p:txBody>
+          <a:bodyPr wrap="square"/>
+          <a:lstStyle/>
+          <a:p>
+            <a:r>
+              <a:t>ollama.chat(...) y ollama.generate(...) aceptan options={...} — hiperparámetros de inferencia</a:t>
+            </a:r>
+          </a:p>
+          <a:p>
+            <a:r>
+              <a:t>Se aplican por llamada: no cambian el modelo descargado, no hay que rebajarlo ni recargarlo</a:t>
+            </a:r>
+          </a:p>
+          <a:p>
+            <a:r>
+              <a:t>El más importante para quien va a montar agentes o RAG (Bloque 4): num_ctx, el contexto</a:t>
             </a:r>
           </a:p>
         </p:txBody>
@@ -6708,7 +7255,7 @@
           <a:lstStyle/>
           <a:p>
             <a:r>
-              <a:t>¿Qué es un embedding?</a:t>
+              <a:t>Parámetros más usados</a:t>
             </a:r>
           </a:p>
         </p:txBody>
@@ -6722,29 +7269,703 @@
           <p:nvPr>
             <p:ph type="body" idx="16" sz="quarter"/>
           </p:nvPr>
+        </p:nvSpPr>
+        <p:spPr/>
+        <p:txBody>
+          <a:bodyPr/>
+          <a:lstStyle/>
+          <a:p/>
+        </p:txBody>
+      </p:sp>
+      <p:graphicFrame>
+        <p:nvGraphicFramePr>
+          <p:cNvPr id="4" name="Table 3"/>
+          <p:cNvGraphicFramePr>
+            <a:graphicFrameLocks noGrp="1"/>
+          </p:cNvGraphicFramePr>
+          <p:nvPr/>
+        </p:nvGraphicFramePr>
+        <p:xfrm>
+          <a:off x="1051560" y="1783080"/>
+          <a:ext cx="10058400" cy="2560320"/>
+        </p:xfrm>
+        <a:graphic>
+          <a:graphicData uri="http://schemas.openxmlformats.org/drawingml/2006/table">
+            <a:tbl>
+              <a:tblPr>
+                <a:tableStyleId>{5C22544A-7EE6-4342-B048-85BDC9FD1C3A}</a:tableStyleId>
+              </a:tblPr>
+              <a:tblGrid>
+                <a:gridCol w="2514600"/>
+                <a:gridCol w="2514600"/>
+                <a:gridCol w="2514600"/>
+                <a:gridCol w="2514600"/>
+              </a:tblGrid>
+              <a:tr h="365760">
+                <a:tc>
+                  <a:txBody>
+                    <a:bodyPr/>
+                    <a:lstStyle/>
+                    <a:p>
+                      <a:r>
+                        <a:rPr sz="1200" b="1">
+                          <a:solidFill>
+                            <a:srgbClr val="FFFFFF"/>
+                          </a:solidFill>
+                          <a:latin typeface="Arial"/>
+                        </a:rPr>
+                        <a:t>Parámetro</a:t>
+                      </a:r>
+                    </a:p>
+                  </a:txBody>
+                  <a:tcPr marL="45000" marR="45000" marT="25000" marB="25000" anchor="ctr">
+                    <a:solidFill>
+                      <a:srgbClr val="CD2D37"/>
+                    </a:solidFill>
+                  </a:tcPr>
+                </a:tc>
+                <a:tc>
+                  <a:txBody>
+                    <a:bodyPr/>
+                    <a:lstStyle/>
+                    <a:p>
+                      <a:r>
+                        <a:rPr sz="1200" b="1">
+                          <a:solidFill>
+                            <a:srgbClr val="FFFFFF"/>
+                          </a:solidFill>
+                          <a:latin typeface="Arial"/>
+                        </a:rPr>
+                        <a:t>Qué controla</a:t>
+                      </a:r>
+                    </a:p>
+                  </a:txBody>
+                  <a:tcPr marL="45000" marR="45000" marT="25000" marB="25000" anchor="ctr">
+                    <a:solidFill>
+                      <a:srgbClr val="CD2D37"/>
+                    </a:solidFill>
+                  </a:tcPr>
+                </a:tc>
+                <a:tc>
+                  <a:txBody>
+                    <a:bodyPr/>
+                    <a:lstStyle/>
+                    <a:p>
+                      <a:r>
+                        <a:rPr sz="1200" b="1">
+                          <a:solidFill>
+                            <a:srgbClr val="FFFFFF"/>
+                          </a:solidFill>
+                          <a:latin typeface="Arial"/>
+                        </a:rPr>
+                        <a:t>Por defecto</a:t>
+                      </a:r>
+                    </a:p>
+                  </a:txBody>
+                  <a:tcPr marL="45000" marR="45000" marT="25000" marB="25000" anchor="ctr">
+                    <a:solidFill>
+                      <a:srgbClr val="CD2D37"/>
+                    </a:solidFill>
+                  </a:tcPr>
+                </a:tc>
+                <a:tc>
+                  <a:txBody>
+                    <a:bodyPr/>
+                    <a:lstStyle/>
+                    <a:p>
+                      <a:r>
+                        <a:rPr sz="1200" b="1">
+                          <a:solidFill>
+                            <a:srgbClr val="FFFFFF"/>
+                          </a:solidFill>
+                          <a:latin typeface="Arial"/>
+                        </a:rPr>
+                        <a:t>Cuándo tocarlo</a:t>
+                      </a:r>
+                    </a:p>
+                  </a:txBody>
+                  <a:tcPr marL="45000" marR="45000" marT="25000" marB="25000" anchor="ctr">
+                    <a:solidFill>
+                      <a:srgbClr val="CD2D37"/>
+                    </a:solidFill>
+                  </a:tcPr>
+                </a:tc>
+              </a:tr>
+              <a:tr h="365760">
+                <a:tc>
+                  <a:txBody>
+                    <a:bodyPr/>
+                    <a:lstStyle/>
+                    <a:p>
+                      <a:r>
+                        <a:rPr sz="1100" b="0">
+                          <a:solidFill>
+                            <a:srgbClr val="465461"/>
+                          </a:solidFill>
+                          <a:latin typeface="Arial"/>
+                        </a:rPr>
+                        <a:t>num_ctx</a:t>
+                      </a:r>
+                    </a:p>
+                  </a:txBody>
+                  <a:tcPr marL="45000" marR="45000" marT="25000" marB="25000" anchor="ctr">
+                    <a:solidFill>
+                      <a:srgbClr val="F1F2F6"/>
+                    </a:solidFill>
+                  </a:tcPr>
+                </a:tc>
+                <a:tc>
+                  <a:txBody>
+                    <a:bodyPr/>
+                    <a:lstStyle/>
+                    <a:p>
+                      <a:r>
+                        <a:rPr sz="1100" b="0">
+                          <a:solidFill>
+                            <a:srgbClr val="465461"/>
+                          </a:solidFill>
+                          <a:latin typeface="Arial"/>
+                        </a:rPr>
+                        <a:t>Ventana de contexto: tokens que el modelo "ve" a la vez (prompt + historial + salida)</a:t>
+                      </a:r>
+                    </a:p>
+                  </a:txBody>
+                  <a:tcPr marL="45000" marR="45000" marT="25000" marB="25000" anchor="ctr">
+                    <a:solidFill>
+                      <a:srgbClr val="F1F2F6"/>
+                    </a:solidFill>
+                  </a:tcPr>
+                </a:tc>
+                <a:tc>
+                  <a:txBody>
+                    <a:bodyPr/>
+                    <a:lstStyle/>
+                    <a:p>
+                      <a:r>
+                        <a:rPr sz="1100" b="0">
+                          <a:solidFill>
+                            <a:srgbClr val="465461"/>
+                          </a:solidFill>
+                          <a:latin typeface="Arial"/>
+                        </a:rPr>
+                        <a:t>4096</a:t>
+                      </a:r>
+                    </a:p>
+                  </a:txBody>
+                  <a:tcPr marL="45000" marR="45000" marT="25000" marB="25000" anchor="ctr">
+                    <a:solidFill>
+                      <a:srgbClr val="F1F2F6"/>
+                    </a:solidFill>
+                  </a:tcPr>
+                </a:tc>
+                <a:tc>
+                  <a:txBody>
+                    <a:bodyPr/>
+                    <a:lstStyle/>
+                    <a:p>
+                      <a:r>
+                        <a:rPr sz="1100" b="0">
+                          <a:solidFill>
+                            <a:srgbClr val="465461"/>
+                          </a:solidFill>
+                          <a:latin typeface="Arial"/>
+                        </a:rPr>
+                        <a:t>Conversaciones largas, RAG con varios documentos, agentes con historial extenso</a:t>
+                      </a:r>
+                    </a:p>
+                  </a:txBody>
+                  <a:tcPr marL="45000" marR="45000" marT="25000" marB="25000" anchor="ctr">
+                    <a:solidFill>
+                      <a:srgbClr val="F1F2F6"/>
+                    </a:solidFill>
+                  </a:tcPr>
+                </a:tc>
+              </a:tr>
+              <a:tr h="365760">
+                <a:tc>
+                  <a:txBody>
+                    <a:bodyPr/>
+                    <a:lstStyle/>
+                    <a:p>
+                      <a:r>
+                        <a:rPr sz="1100" b="0">
+                          <a:solidFill>
+                            <a:srgbClr val="465461"/>
+                          </a:solidFill>
+                          <a:latin typeface="Arial"/>
+                        </a:rPr>
+                        <a:t>temperature</a:t>
+                      </a:r>
+                    </a:p>
+                  </a:txBody>
+                  <a:tcPr marL="45000" marR="45000" marT="25000" marB="25000" anchor="ctr">
+                    <a:solidFill>
+                      <a:srgbClr val="FFFFFF"/>
+                    </a:solidFill>
+                  </a:tcPr>
+                </a:tc>
+                <a:tc>
+                  <a:txBody>
+                    <a:bodyPr/>
+                    <a:lstStyle/>
+                    <a:p>
+                      <a:r>
+                        <a:rPr sz="1100" b="0">
+                          <a:solidFill>
+                            <a:srgbClr val="465461"/>
+                          </a:solidFill>
+                          <a:latin typeface="Arial"/>
+                        </a:rPr>
+                        <a:t>Aleatoriedad de la generación (0 = determinista, 1+ = creativo)</a:t>
+                      </a:r>
+                    </a:p>
+                  </a:txBody>
+                  <a:tcPr marL="45000" marR="45000" marT="25000" marB="25000" anchor="ctr">
+                    <a:solidFill>
+                      <a:srgbClr val="FFFFFF"/>
+                    </a:solidFill>
+                  </a:tcPr>
+                </a:tc>
+                <a:tc>
+                  <a:txBody>
+                    <a:bodyPr/>
+                    <a:lstStyle/>
+                    <a:p>
+                      <a:r>
+                        <a:rPr sz="1100" b="0">
+                          <a:solidFill>
+                            <a:srgbClr val="465461"/>
+                          </a:solidFill>
+                          <a:latin typeface="Arial"/>
+                        </a:rPr>
+                        <a:t>0.8</a:t>
+                      </a:r>
+                    </a:p>
+                  </a:txBody>
+                  <a:tcPr marL="45000" marR="45000" marT="25000" marB="25000" anchor="ctr">
+                    <a:solidFill>
+                      <a:srgbClr val="FFFFFF"/>
+                    </a:solidFill>
+                  </a:tcPr>
+                </a:tc>
+                <a:tc>
+                  <a:txBody>
+                    <a:bodyPr/>
+                    <a:lstStyle/>
+                    <a:p>
+                      <a:r>
+                        <a:rPr sz="1100" b="0">
+                          <a:solidFill>
+                            <a:srgbClr val="465461"/>
+                          </a:solidFill>
+                          <a:latin typeface="Arial"/>
+                        </a:rPr>
+                        <a:t>Bajar para extracción/clasificación consistente; subir para texto creativo</a:t>
+                      </a:r>
+                    </a:p>
+                  </a:txBody>
+                  <a:tcPr marL="45000" marR="45000" marT="25000" marB="25000" anchor="ctr">
+                    <a:solidFill>
+                      <a:srgbClr val="FFFFFF"/>
+                    </a:solidFill>
+                  </a:tcPr>
+                </a:tc>
+              </a:tr>
+              <a:tr h="365760">
+                <a:tc>
+                  <a:txBody>
+                    <a:bodyPr/>
+                    <a:lstStyle/>
+                    <a:p>
+                      <a:r>
+                        <a:rPr sz="1100" b="0">
+                          <a:solidFill>
+                            <a:srgbClr val="465461"/>
+                          </a:solidFill>
+                          <a:latin typeface="Arial"/>
+                        </a:rPr>
+                        <a:t>top_p / top_k</a:t>
+                      </a:r>
+                    </a:p>
+                  </a:txBody>
+                  <a:tcPr marL="45000" marR="45000" marT="25000" marB="25000" anchor="ctr">
+                    <a:solidFill>
+                      <a:srgbClr val="F1F2F6"/>
+                    </a:solidFill>
+                  </a:tcPr>
+                </a:tc>
+                <a:tc>
+                  <a:txBody>
+                    <a:bodyPr/>
+                    <a:lstStyle/>
+                    <a:p>
+                      <a:r>
+                        <a:rPr sz="1100" b="0">
+                          <a:solidFill>
+                            <a:srgbClr val="465461"/>
+                          </a:solidFill>
+                          <a:latin typeface="Arial"/>
+                        </a:rPr>
+                        <a:t>Recortan el conjunto de tokens candidatos antes de muestrear</a:t>
+                      </a:r>
+                    </a:p>
+                  </a:txBody>
+                  <a:tcPr marL="45000" marR="45000" marT="25000" marB="25000" anchor="ctr">
+                    <a:solidFill>
+                      <a:srgbClr val="F1F2F6"/>
+                    </a:solidFill>
+                  </a:tcPr>
+                </a:tc>
+                <a:tc>
+                  <a:txBody>
+                    <a:bodyPr/>
+                    <a:lstStyle/>
+                    <a:p>
+                      <a:r>
+                        <a:rPr sz="1100" b="0">
+                          <a:solidFill>
+                            <a:srgbClr val="465461"/>
+                          </a:solidFill>
+                          <a:latin typeface="Arial"/>
+                        </a:rPr>
+                        <a:t>0.9 / 40</a:t>
+                      </a:r>
+                    </a:p>
+                  </a:txBody>
+                  <a:tcPr marL="45000" marR="45000" marT="25000" marB="25000" anchor="ctr">
+                    <a:solidFill>
+                      <a:srgbClr val="F1F2F6"/>
+                    </a:solidFill>
+                  </a:tcPr>
+                </a:tc>
+                <a:tc>
+                  <a:txBody>
+                    <a:bodyPr/>
+                    <a:lstStyle/>
+                    <a:p>
+                      <a:r>
+                        <a:rPr sz="1100" b="0">
+                          <a:solidFill>
+                            <a:srgbClr val="465461"/>
+                          </a:solidFill>
+                          <a:latin typeface="Arial"/>
+                        </a:rPr>
+                        <a:t>Ajuste fino junto con temperature, casi nunca solos</a:t>
+                      </a:r>
+                    </a:p>
+                  </a:txBody>
+                  <a:tcPr marL="45000" marR="45000" marT="25000" marB="25000" anchor="ctr">
+                    <a:solidFill>
+                      <a:srgbClr val="F1F2F6"/>
+                    </a:solidFill>
+                  </a:tcPr>
+                </a:tc>
+              </a:tr>
+              <a:tr h="365760">
+                <a:tc>
+                  <a:txBody>
+                    <a:bodyPr/>
+                    <a:lstStyle/>
+                    <a:p>
+                      <a:r>
+                        <a:rPr sz="1100" b="0">
+                          <a:solidFill>
+                            <a:srgbClr val="465461"/>
+                          </a:solidFill>
+                          <a:latin typeface="Arial"/>
+                        </a:rPr>
+                        <a:t>num_predict</a:t>
+                      </a:r>
+                    </a:p>
+                  </a:txBody>
+                  <a:tcPr marL="45000" marR="45000" marT="25000" marB="25000" anchor="ctr">
+                    <a:solidFill>
+                      <a:srgbClr val="FFFFFF"/>
+                    </a:solidFill>
+                  </a:tcPr>
+                </a:tc>
+                <a:tc>
+                  <a:txBody>
+                    <a:bodyPr/>
+                    <a:lstStyle/>
+                    <a:p>
+                      <a:r>
+                        <a:rPr sz="1100" b="0">
+                          <a:solidFill>
+                            <a:srgbClr val="465461"/>
+                          </a:solidFill>
+                          <a:latin typeface="Arial"/>
+                        </a:rPr>
+                        <a:t>Máximo de tokens a generar en la respuesta</a:t>
+                      </a:r>
+                    </a:p>
+                  </a:txBody>
+                  <a:tcPr marL="45000" marR="45000" marT="25000" marB="25000" anchor="ctr">
+                    <a:solidFill>
+                      <a:srgbClr val="FFFFFF"/>
+                    </a:solidFill>
+                  </a:tcPr>
+                </a:tc>
+                <a:tc>
+                  <a:txBody>
+                    <a:bodyPr/>
+                    <a:lstStyle/>
+                    <a:p>
+                      <a:r>
+                        <a:rPr sz="1100" b="0">
+                          <a:solidFill>
+                            <a:srgbClr val="465461"/>
+                          </a:solidFill>
+                          <a:latin typeface="Arial"/>
+                        </a:rPr>
+                        <a:t>-1 (sin límite)</a:t>
+                      </a:r>
+                    </a:p>
+                  </a:txBody>
+                  <a:tcPr marL="45000" marR="45000" marT="25000" marB="25000" anchor="ctr">
+                    <a:solidFill>
+                      <a:srgbClr val="FFFFFF"/>
+                    </a:solidFill>
+                  </a:tcPr>
+                </a:tc>
+                <a:tc>
+                  <a:txBody>
+                    <a:bodyPr/>
+                    <a:lstStyle/>
+                    <a:p>
+                      <a:r>
+                        <a:rPr sz="1100" b="0">
+                          <a:solidFill>
+                            <a:srgbClr val="465461"/>
+                          </a:solidFill>
+                          <a:latin typeface="Arial"/>
+                        </a:rPr>
+                        <a:t>Acotar respuestas largas o limitar tiempo de cómputo</a:t>
+                      </a:r>
+                    </a:p>
+                  </a:txBody>
+                  <a:tcPr marL="45000" marR="45000" marT="25000" marB="25000" anchor="ctr">
+                    <a:solidFill>
+                      <a:srgbClr val="FFFFFF"/>
+                    </a:solidFill>
+                  </a:tcPr>
+                </a:tc>
+              </a:tr>
+              <a:tr h="365760">
+                <a:tc>
+                  <a:txBody>
+                    <a:bodyPr/>
+                    <a:lstStyle/>
+                    <a:p>
+                      <a:r>
+                        <a:rPr sz="1100" b="0">
+                          <a:solidFill>
+                            <a:srgbClr val="465461"/>
+                          </a:solidFill>
+                          <a:latin typeface="Arial"/>
+                        </a:rPr>
+                        <a:t>repeat_penalty</a:t>
+                      </a:r>
+                    </a:p>
+                  </a:txBody>
+                  <a:tcPr marL="45000" marR="45000" marT="25000" marB="25000" anchor="ctr">
+                    <a:solidFill>
+                      <a:srgbClr val="F1F2F6"/>
+                    </a:solidFill>
+                  </a:tcPr>
+                </a:tc>
+                <a:tc>
+                  <a:txBody>
+                    <a:bodyPr/>
+                    <a:lstStyle/>
+                    <a:p>
+                      <a:r>
+                        <a:rPr sz="1100" b="0">
+                          <a:solidFill>
+                            <a:srgbClr val="465461"/>
+                          </a:solidFill>
+                          <a:latin typeface="Arial"/>
+                        </a:rPr>
+                        <a:t>Penaliza repetir las mismas palabras o frases</a:t>
+                      </a:r>
+                    </a:p>
+                  </a:txBody>
+                  <a:tcPr marL="45000" marR="45000" marT="25000" marB="25000" anchor="ctr">
+                    <a:solidFill>
+                      <a:srgbClr val="F1F2F6"/>
+                    </a:solidFill>
+                  </a:tcPr>
+                </a:tc>
+                <a:tc>
+                  <a:txBody>
+                    <a:bodyPr/>
+                    <a:lstStyle/>
+                    <a:p>
+                      <a:r>
+                        <a:rPr sz="1100" b="0">
+                          <a:solidFill>
+                            <a:srgbClr val="465461"/>
+                          </a:solidFill>
+                          <a:latin typeface="Arial"/>
+                        </a:rPr>
+                        <a:t>1.1</a:t>
+                      </a:r>
+                    </a:p>
+                  </a:txBody>
+                  <a:tcPr marL="45000" marR="45000" marT="25000" marB="25000" anchor="ctr">
+                    <a:solidFill>
+                      <a:srgbClr val="F1F2F6"/>
+                    </a:solidFill>
+                  </a:tcPr>
+                </a:tc>
+                <a:tc>
+                  <a:txBody>
+                    <a:bodyPr/>
+                    <a:lstStyle/>
+                    <a:p>
+                      <a:r>
+                        <a:rPr sz="1100" b="0">
+                          <a:solidFill>
+                            <a:srgbClr val="465461"/>
+                          </a:solidFill>
+                          <a:latin typeface="Arial"/>
+                        </a:rPr>
+                        <a:t>Si el modelo entra en bucle repitiendo texto</a:t>
+                      </a:r>
+                    </a:p>
+                  </a:txBody>
+                  <a:tcPr marL="45000" marR="45000" marT="25000" marB="25000" anchor="ctr">
+                    <a:solidFill>
+                      <a:srgbClr val="F1F2F6"/>
+                    </a:solidFill>
+                  </a:tcPr>
+                </a:tc>
+              </a:tr>
+              <a:tr h="365760">
+                <a:tc>
+                  <a:txBody>
+                    <a:bodyPr/>
+                    <a:lstStyle/>
+                    <a:p>
+                      <a:r>
+                        <a:rPr sz="1100" b="0">
+                          <a:solidFill>
+                            <a:srgbClr val="465461"/>
+                          </a:solidFill>
+                          <a:latin typeface="Arial"/>
+                        </a:rPr>
+                        <a:t>seed</a:t>
+                      </a:r>
+                    </a:p>
+                  </a:txBody>
+                  <a:tcPr marL="45000" marR="45000" marT="25000" marB="25000" anchor="ctr">
+                    <a:solidFill>
+                      <a:srgbClr val="FFFFFF"/>
+                    </a:solidFill>
+                  </a:tcPr>
+                </a:tc>
+                <a:tc>
+                  <a:txBody>
+                    <a:bodyPr/>
+                    <a:lstStyle/>
+                    <a:p>
+                      <a:r>
+                        <a:rPr sz="1100" b="0">
+                          <a:solidFill>
+                            <a:srgbClr val="465461"/>
+                          </a:solidFill>
+                          <a:latin typeface="Arial"/>
+                        </a:rPr>
+                        <a:t>Fija la semilla aleatoria de muestreo</a:t>
+                      </a:r>
+                    </a:p>
+                  </a:txBody>
+                  <a:tcPr marL="45000" marR="45000" marT="25000" marB="25000" anchor="ctr">
+                    <a:solidFill>
+                      <a:srgbClr val="FFFFFF"/>
+                    </a:solidFill>
+                  </a:tcPr>
+                </a:tc>
+                <a:tc>
+                  <a:txBody>
+                    <a:bodyPr/>
+                    <a:lstStyle/>
+                    <a:p>
+                      <a:r>
+                        <a:rPr sz="1100" b="0">
+                          <a:solidFill>
+                            <a:srgbClr val="465461"/>
+                          </a:solidFill>
+                          <a:latin typeface="Arial"/>
+                        </a:rPr>
+                        <a:t>aleatoria</a:t>
+                      </a:r>
+                    </a:p>
+                  </a:txBody>
+                  <a:tcPr marL="45000" marR="45000" marT="25000" marB="25000" anchor="ctr">
+                    <a:solidFill>
+                      <a:srgbClr val="FFFFFF"/>
+                    </a:solidFill>
+                  </a:tcPr>
+                </a:tc>
+                <a:tc>
+                  <a:txBody>
+                    <a:bodyPr/>
+                    <a:lstStyle/>
+                    <a:p>
+                      <a:r>
+                        <a:rPr sz="1100" b="0">
+                          <a:solidFill>
+                            <a:srgbClr val="465461"/>
+                          </a:solidFill>
+                          <a:latin typeface="Arial"/>
+                        </a:rPr>
+                        <a:t>Reproducibilidad en tests o demos</a:t>
+                      </a:r>
+                    </a:p>
+                  </a:txBody>
+                  <a:tcPr marL="45000" marR="45000" marT="25000" marB="25000" anchor="ctr">
+                    <a:solidFill>
+                      <a:srgbClr val="FFFFFF"/>
+                    </a:solidFill>
+                  </a:tcPr>
+                </a:tc>
+              </a:tr>
+            </a:tbl>
+          </a:graphicData>
+        </a:graphic>
+      </p:graphicFrame>
+      <p:sp>
+        <p:nvSpPr>
+          <p:cNvPr id="5" name="TextBox 4"/>
+          <p:cNvSpPr txBox="1"/>
+          <p:nvPr/>
         </p:nvSpPr>
         <p:spPr>
           <a:xfrm>
-            <a:off x="1073427" y="1711816"/>
-            <a:ext cx="10084904" cy="3873058"/>
+            <a:off x="1051560" y="5760720"/>
+            <a:ext cx="10058400" cy="320040"/>
           </a:xfrm>
+          <a:prstGeom prst="rect">
+            <a:avLst/>
+          </a:prstGeom>
+          <a:noFill/>
         </p:spPr>
         <p:txBody>
-          <a:bodyPr wrap="square"/>
+          <a:bodyPr wrap="square">
+            <a:spAutoFit/>
+          </a:bodyPr>
           <a:lstStyle/>
           <a:p>
-            <a:r>
-              <a:t>Convierte un texto en un vector de números que captura su significado</a:t>
-            </a:r>
-          </a:p>
-          <a:p>
-            <a:r>
-              <a:t>Textos parecidos → vectores cercanos en el espacio</a:t>
-            </a:r>
-          </a:p>
-          <a:p>
-            <a:r>
-              <a:t>No genera texto: solo lo representa para poder compararlo</a:t>
+            <a:pPr algn="l"/>
+            <a:r>
+              <a:rPr sz="1000" b="0">
+                <a:solidFill>
+                  <a:srgbClr val="707888"/>
+                </a:solidFill>
+                <a:latin typeface="Arial"/>
+              </a:rPr>
+              <a:t>ℹ  Referencia — no hace falta memorizarla, se busca cuando hace falta.</a:t>
             </a:r>
           </a:p>
         </p:txBody>
@@ -6758,6 +7979,357 @@
 </file>
 
 <file path=ppt/slides/slide14.xml><?xml version="1.0" encoding="utf-8"?>
+<p:sld xmlns:a="http://schemas.openxmlformats.org/drawingml/2006/main" xmlns:p="http://schemas.openxmlformats.org/presentationml/2006/main" xmlns:r="http://schemas.openxmlformats.org/officeDocument/2006/relationships">
+  <p:cSld>
+    <p:spTree>
+      <p:nvGrpSpPr>
+        <p:cNvPr id="1" name=""/>
+        <p:cNvGrpSpPr/>
+        <p:nvPr/>
+      </p:nvGrpSpPr>
+      <p:grpSpPr/>
+      <p:sp>
+        <p:nvSpPr>
+          <p:cNvPr id="2" name="Text Placeholder 1"/>
+          <p:cNvSpPr>
+            <a:spLocks noGrp="1"/>
+          </p:cNvSpPr>
+          <p:nvPr>
+            <p:ph type="body" idx="13" sz="quarter"/>
+          </p:nvPr>
+        </p:nvSpPr>
+        <p:spPr/>
+        <p:txBody>
+          <a:bodyPr wrap="square"/>
+          <a:lstStyle/>
+          <a:p>
+            <a:r>
+              <a:t>num_ctx en la práctica</a:t>
+            </a:r>
+          </a:p>
+        </p:txBody>
+      </p:sp>
+      <p:sp>
+        <p:nvSpPr>
+          <p:cNvPr id="3" name="Text Placeholder 2"/>
+          <p:cNvSpPr>
+            <a:spLocks noGrp="1"/>
+          </p:cNvSpPr>
+          <p:nvPr>
+            <p:ph type="body" idx="16" sz="quarter"/>
+          </p:nvPr>
+        </p:nvSpPr>
+        <p:spPr/>
+        <p:txBody>
+          <a:bodyPr/>
+          <a:lstStyle/>
+          <a:p/>
+        </p:txBody>
+      </p:sp>
+      <p:sp>
+        <p:nvSpPr>
+          <p:cNvPr id="4" name="TextBox 3"/>
+          <p:cNvSpPr txBox="1"/>
+          <p:nvPr/>
+        </p:nvSpPr>
+        <p:spPr>
+          <a:xfrm>
+            <a:off x="1051560" y="1828800"/>
+            <a:ext cx="10058400" cy="502920"/>
+          </a:xfrm>
+          <a:prstGeom prst="rect">
+            <a:avLst/>
+          </a:prstGeom>
+          <a:noFill/>
+        </p:spPr>
+        <p:txBody>
+          <a:bodyPr wrap="square">
+            <a:spAutoFit/>
+          </a:bodyPr>
+          <a:lstStyle/>
+          <a:p>
+            <a:pPr algn="l"/>
+            <a:r>
+              <a:rPr sz="1600" b="0">
+                <a:solidFill>
+                  <a:srgbClr val="465461"/>
+                </a:solidFill>
+                <a:latin typeface="Arial"/>
+              </a:rPr>
+              <a:t>Si el historial (o los documentos en RAG) supera la ventana de contexto, Ollama descarta lo más viejo sin avisar:</a:t>
+            </a:r>
+          </a:p>
+        </p:txBody>
+      </p:sp>
+      <p:sp>
+        <p:nvSpPr>
+          <p:cNvPr id="5" name="Rectangle 4"/>
+          <p:cNvSpPr/>
+          <p:nvPr/>
+        </p:nvSpPr>
+        <p:spPr>
+          <a:xfrm>
+            <a:off x="1005840" y="2377440"/>
+            <a:ext cx="10149840" cy="3429000"/>
+          </a:xfrm>
+          <a:prstGeom prst="rect">
+            <a:avLst/>
+          </a:prstGeom>
+          <a:solidFill>
+            <a:srgbClr val="0D1B2A"/>
+          </a:solidFill>
+          <a:ln>
+            <a:noFill/>
+          </a:ln>
+        </p:spPr>
+        <p:style>
+          <a:lnRef idx="1">
+            <a:schemeClr val="accent1"/>
+          </a:lnRef>
+          <a:fillRef idx="3">
+            <a:schemeClr val="accent1"/>
+          </a:fillRef>
+          <a:effectRef idx="2">
+            <a:schemeClr val="accent1"/>
+          </a:effectRef>
+          <a:fontRef idx="minor">
+            <a:schemeClr val="lt1"/>
+          </a:fontRef>
+        </p:style>
+        <p:txBody>
+          <a:bodyPr rtlCol="0" anchor="ctr"/>
+          <a:lstStyle/>
+          <a:p>
+            <a:pPr algn="ctr"/>
+          </a:p>
+        </p:txBody>
+      </p:sp>
+      <p:sp>
+        <p:nvSpPr>
+          <p:cNvPr id="6" name="TextBox 5"/>
+          <p:cNvSpPr txBox="1"/>
+          <p:nvPr/>
+        </p:nvSpPr>
+        <p:spPr>
+          <a:xfrm>
+            <a:off x="1188720" y="2514600"/>
+            <a:ext cx="9784080" cy="3154680"/>
+          </a:xfrm>
+          <a:prstGeom prst="rect">
+            <a:avLst/>
+          </a:prstGeom>
+          <a:noFill/>
+        </p:spPr>
+        <p:txBody>
+          <a:bodyPr wrap="none">
+            <a:spAutoFit/>
+          </a:bodyPr>
+          <a:lstStyle/>
+          <a:p>
+            <a:r>
+              <a:rPr sz="1400">
+                <a:solidFill>
+                  <a:srgbClr val="A8FF78"/>
+                </a:solidFill>
+                <a:latin typeface="Consolas"/>
+              </a:rPr>
+              <a:t>respuesta = ollama.chat(
+    model="qwen2.5:14b",
+    messages=historial_largo,
+    options={"num_ctx": 8192},   # default: 4096
+)</a:t>
+            </a:r>
+          </a:p>
+        </p:txBody>
+      </p:sp>
+      <p:sp>
+        <p:nvSpPr>
+          <p:cNvPr id="7" name="TextBox 6"/>
+          <p:cNvSpPr txBox="1"/>
+          <p:nvPr/>
+        </p:nvSpPr>
+        <p:spPr>
+          <a:xfrm>
+            <a:off x="1051560" y="5760720"/>
+            <a:ext cx="10058400" cy="365760"/>
+          </a:xfrm>
+          <a:prstGeom prst="rect">
+            <a:avLst/>
+          </a:prstGeom>
+          <a:noFill/>
+        </p:spPr>
+        <p:txBody>
+          <a:bodyPr wrap="square">
+            <a:spAutoFit/>
+          </a:bodyPr>
+          <a:lstStyle/>
+          <a:p>
+            <a:pPr algn="l"/>
+            <a:r>
+              <a:rPr sz="1100" b="0">
+                <a:solidFill>
+                  <a:srgbClr val="707888"/>
+                </a:solidFill>
+                <a:latin typeface="Arial"/>
+              </a:rPr>
+              <a:t>ℹ  Subir num_ctx consume más RAM/VRAM — el modelo se recarga con la ventana nueva.</a:t>
+            </a:r>
+          </a:p>
+        </p:txBody>
+      </p:sp>
+    </p:spTree>
+  </p:cSld>
+  <p:clrMapOvr>
+    <a:masterClrMapping/>
+  </p:clrMapOvr>
+</p:sld>
+</file>
+
+<file path=ppt/slides/slide15.xml><?xml version="1.0" encoding="utf-8"?>
+<p:sld xmlns:a="http://schemas.openxmlformats.org/drawingml/2006/main" xmlns:p="http://schemas.openxmlformats.org/presentationml/2006/main" xmlns:r="http://schemas.openxmlformats.org/officeDocument/2006/relationships">
+  <p:cSld>
+    <p:spTree>
+      <p:nvGrpSpPr>
+        <p:cNvPr id="1" name=""/>
+        <p:cNvGrpSpPr/>
+        <p:nvPr/>
+      </p:nvGrpSpPr>
+      <p:grpSpPr/>
+      <p:sp>
+        <p:nvSpPr>
+          <p:cNvPr id="2" name="Text Placeholder 1"/>
+          <p:cNvSpPr>
+            <a:spLocks noGrp="1"/>
+          </p:cNvSpPr>
+          <p:nvPr>
+            <p:ph type="body" idx="10" sz="quarter"/>
+          </p:nvPr>
+        </p:nvSpPr>
+        <p:spPr/>
+        <p:txBody>
+          <a:bodyPr wrap="square"/>
+          <a:lstStyle/>
+          <a:p>
+            <a:pPr algn="ctr"/>
+            <a:r>
+              <a:rPr sz="1700" b="1">
+                <a:solidFill>
+                  <a:srgbClr val="CD2D37"/>
+                </a:solidFill>
+                <a:latin typeface="Arial"/>
+              </a:rPr>
+              <a:t>SECCIÓN 3</a:t>
+            </a:r>
+          </a:p>
+          <a:p>
+            <a:pPr algn="ctr"/>
+            <a:r>
+              <a:t>Entendiendo los modelos</a:t>
+            </a:r>
+          </a:p>
+          <a:p>
+            <a:pPr algn="ctr"/>
+            <a:r>
+              <a:rPr sz="1600">
+                <a:solidFill>
+                  <a:srgbClr val="D6DAE2"/>
+                </a:solidFill>
+                <a:latin typeface="Arial"/>
+              </a:rPr>
+              <a:t>Embeddings, generativos y cuantización</a:t>
+            </a:r>
+          </a:p>
+        </p:txBody>
+      </p:sp>
+    </p:spTree>
+  </p:cSld>
+  <p:clrMapOvr>
+    <a:masterClrMapping/>
+  </p:clrMapOvr>
+</p:sld>
+</file>
+
+<file path=ppt/slides/slide16.xml><?xml version="1.0" encoding="utf-8"?>
+<p:sld xmlns:a="http://schemas.openxmlformats.org/drawingml/2006/main" xmlns:p="http://schemas.openxmlformats.org/presentationml/2006/main" xmlns:r="http://schemas.openxmlformats.org/officeDocument/2006/relationships">
+  <p:cSld>
+    <p:spTree>
+      <p:nvGrpSpPr>
+        <p:cNvPr id="1" name=""/>
+        <p:cNvGrpSpPr/>
+        <p:nvPr/>
+      </p:nvGrpSpPr>
+      <p:grpSpPr/>
+      <p:sp>
+        <p:nvSpPr>
+          <p:cNvPr id="2" name="Text Placeholder 1"/>
+          <p:cNvSpPr>
+            <a:spLocks noGrp="1"/>
+          </p:cNvSpPr>
+          <p:nvPr>
+            <p:ph type="body" idx="13" sz="quarter"/>
+          </p:nvPr>
+        </p:nvSpPr>
+        <p:spPr/>
+        <p:txBody>
+          <a:bodyPr wrap="square"/>
+          <a:lstStyle/>
+          <a:p>
+            <a:r>
+              <a:t>¿Qué es un embedding?</a:t>
+            </a:r>
+          </a:p>
+        </p:txBody>
+      </p:sp>
+      <p:sp>
+        <p:nvSpPr>
+          <p:cNvPr id="3" name="Text Placeholder 2"/>
+          <p:cNvSpPr>
+            <a:spLocks noGrp="1"/>
+          </p:cNvSpPr>
+          <p:nvPr>
+            <p:ph type="body" idx="16" sz="quarter"/>
+          </p:nvPr>
+        </p:nvSpPr>
+        <p:spPr>
+          <a:xfrm>
+            <a:off x="1073427" y="1711816"/>
+            <a:ext cx="10084904" cy="3873058"/>
+          </a:xfrm>
+        </p:spPr>
+        <p:txBody>
+          <a:bodyPr wrap="square"/>
+          <a:lstStyle/>
+          <a:p>
+            <a:r>
+              <a:t>Convierte un texto en un vector de números que captura su significado</a:t>
+            </a:r>
+          </a:p>
+          <a:p>
+            <a:r>
+              <a:t>Textos parecidos → vectores cercanos en el espacio</a:t>
+            </a:r>
+          </a:p>
+          <a:p>
+            <a:r>
+              <a:t>No genera texto: solo lo representa para poder compararlo</a:t>
+            </a:r>
+          </a:p>
+          <a:p>
+            <a:r>
+              <a:t>qwen3-embedding: cada texto → un vector de 4096 números, sin importar su longitud</a:t>
+            </a:r>
+          </a:p>
+        </p:txBody>
+      </p:sp>
+    </p:spTree>
+  </p:cSld>
+  <p:clrMapOvr>
+    <a:masterClrMapping/>
+  </p:clrMapOvr>
+</p:sld>
+</file>
+
+<file path=ppt/slides/slide17.xml><?xml version="1.0" encoding="utf-8"?>
 <p:sld xmlns:a="http://schemas.openxmlformats.org/drawingml/2006/main" xmlns:p="http://schemas.openxmlformats.org/presentationml/2006/main" xmlns:r="http://schemas.openxmlformats.org/officeDocument/2006/relationships">
   <p:cSld>
     <p:spTree>
@@ -6872,7 +8444,7 @@
 </p:sld>
 </file>
 
-<file path=ppt/slides/slide15.xml><?xml version="1.0" encoding="utf-8"?>
+<file path=ppt/slides/slide18.xml><?xml version="1.0" encoding="utf-8"?>
 <p:sld xmlns:a="http://schemas.openxmlformats.org/drawingml/2006/main" xmlns:p="http://schemas.openxmlformats.org/presentationml/2006/main" xmlns:r="http://schemas.openxmlformats.org/officeDocument/2006/relationships">
   <p:cSld>
     <p:spTree>
@@ -6934,6 +8506,11 @@
           </a:p>
           <a:p>
             <a:r>
+              <a:t>Cada palabra nueva es una pasada COMPLETA por el modelo, no un paso parcial</a:t>
+            </a:r>
+          </a:p>
+          <a:p>
+            <a:r>
               <a:t>Es lo que usamos para NER, clasificación y resúmenes</a:t>
             </a:r>
           </a:p>
@@ -6947,7 +8524,266 @@
 </p:sld>
 </file>
 
-<file path=ppt/slides/slide16.xml><?xml version="1.0" encoding="utf-8"?>
+<file path=ppt/slides/slide19.xml><?xml version="1.0" encoding="utf-8"?>
+<p:sld xmlns:a="http://schemas.openxmlformats.org/drawingml/2006/main" xmlns:p="http://schemas.openxmlformats.org/presentationml/2006/main" xmlns:r="http://schemas.openxmlformats.org/officeDocument/2006/relationships">
+  <p:cSld>
+    <p:spTree>
+      <p:nvGrpSpPr>
+        <p:cNvPr id="1" name=""/>
+        <p:cNvGrpSpPr/>
+        <p:nvPr/>
+      </p:nvGrpSpPr>
+      <p:grpSpPr/>
+      <p:sp>
+        <p:nvSpPr>
+          <p:cNvPr id="2" name="Text Placeholder 1"/>
+          <p:cNvSpPr>
+            <a:spLocks noGrp="1"/>
+          </p:cNvSpPr>
+          <p:nvPr>
+            <p:ph type="body" idx="13" sz="quarter"/>
+          </p:nvPr>
+        </p:nvSpPr>
+        <p:spPr/>
+        <p:txBody>
+          <a:bodyPr wrap="square"/>
+          <a:lstStyle/>
+          <a:p>
+            <a:r>
+              <a:t>Cómo genera texto un modelo, paso a paso</a:t>
+            </a:r>
+          </a:p>
+        </p:txBody>
+      </p:sp>
+      <p:sp>
+        <p:nvSpPr>
+          <p:cNvPr id="3" name="Text Placeholder 2"/>
+          <p:cNvSpPr>
+            <a:spLocks noGrp="1"/>
+          </p:cNvSpPr>
+          <p:nvPr>
+            <p:ph type="body" idx="16" sz="quarter"/>
+          </p:nvPr>
+        </p:nvSpPr>
+        <p:spPr/>
+        <p:txBody>
+          <a:bodyPr/>
+          <a:lstStyle/>
+          <a:p/>
+        </p:txBody>
+      </p:sp>
+      <p:pic>
+        <p:nvPicPr>
+          <p:cNvPr id="4" name="Picture 3" descr="generation_loop_diagram.png"/>
+          <p:cNvPicPr>
+            <a:picLocks noChangeAspect="1"/>
+          </p:cNvPicPr>
+          <p:nvPr/>
+        </p:nvPicPr>
+        <p:blipFill>
+          <a:blip r:embed="rId2"/>
+          <a:stretch>
+            <a:fillRect/>
+          </a:stretch>
+        </p:blipFill>
+        <p:spPr>
+          <a:xfrm>
+            <a:off x="3212870" y="2240280"/>
+            <a:ext cx="5735780" cy="3291839"/>
+          </a:xfrm>
+          <a:prstGeom prst="rect">
+            <a:avLst/>
+          </a:prstGeom>
+        </p:spPr>
+      </p:pic>
+      <p:sp>
+        <p:nvSpPr>
+          <p:cNvPr id="5" name="TextBox 4"/>
+          <p:cNvSpPr txBox="1"/>
+          <p:nvPr/>
+        </p:nvSpPr>
+        <p:spPr>
+          <a:xfrm>
+            <a:off x="1051560" y="5623559"/>
+            <a:ext cx="10058400" cy="365760"/>
+          </a:xfrm>
+          <a:prstGeom prst="rect">
+            <a:avLst/>
+          </a:prstGeom>
+          <a:noFill/>
+        </p:spPr>
+        <p:txBody>
+          <a:bodyPr wrap="square">
+            <a:spAutoFit/>
+          </a:bodyPr>
+          <a:lstStyle/>
+          <a:p>
+            <a:pPr algn="ctr"/>
+            <a:r>
+              <a:rPr sz="1200" b="0">
+                <a:solidFill>
+                  <a:srgbClr val="465461"/>
+                </a:solidFill>
+                <a:latin typeface="Arial"/>
+              </a:rPr>
+              <a:t>Cada palabra nueva sale de una pasada completa por las 48 capas del modelo — la palabra se agrega al texto y se vuelve a pasar todo por el modelo para la siguiente.</a:t>
+            </a:r>
+          </a:p>
+        </p:txBody>
+      </p:sp>
+    </p:spTree>
+  </p:cSld>
+  <p:clrMapOvr>
+    <a:masterClrMapping/>
+  </p:clrMapOvr>
+</p:sld>
+</file>
+
+<file path=ppt/slides/slide2.xml><?xml version="1.0" encoding="utf-8"?>
+<p:sld xmlns:a="http://schemas.openxmlformats.org/drawingml/2006/main" xmlns:p="http://schemas.openxmlformats.org/presentationml/2006/main" xmlns:r="http://schemas.openxmlformats.org/officeDocument/2006/relationships">
+  <p:cSld>
+    <p:spTree>
+      <p:nvGrpSpPr>
+        <p:cNvPr id="1" name=""/>
+        <p:cNvGrpSpPr/>
+        <p:nvPr/>
+      </p:nvGrpSpPr>
+      <p:grpSpPr/>
+      <p:sp>
+        <p:nvSpPr>
+          <p:cNvPr id="2" name="Text Placeholder 1"/>
+          <p:cNvSpPr>
+            <a:spLocks noGrp="1"/>
+          </p:cNvSpPr>
+          <p:nvPr>
+            <p:ph type="body" idx="10" sz="quarter"/>
+          </p:nvPr>
+        </p:nvSpPr>
+        <p:spPr/>
+        <p:txBody>
+          <a:bodyPr wrap="square"/>
+          <a:lstStyle/>
+          <a:p>
+            <a:pPr algn="ctr"/>
+            <a:r>
+              <a:rPr sz="1700" b="1">
+                <a:solidFill>
+                  <a:srgbClr val="CD2D37"/>
+                </a:solidFill>
+                <a:latin typeface="Arial"/>
+              </a:rPr>
+              <a:t>SECCIÓN 1</a:t>
+            </a:r>
+          </a:p>
+          <a:p>
+            <a:pPr algn="ctr"/>
+            <a:r>
+              <a:t>Gestión de dependencias con uv</a:t>
+            </a:r>
+          </a:p>
+          <a:p>
+            <a:pPr algn="ctr"/>
+            <a:r>
+              <a:rPr sz="1600">
+                <a:solidFill>
+                  <a:srgbClr val="D6DAE2"/>
+                </a:solidFill>
+                <a:latin typeface="Arial"/>
+              </a:rPr>
+              <a:t>Sin magia, simple</a:t>
+            </a:r>
+          </a:p>
+        </p:txBody>
+      </p:sp>
+    </p:spTree>
+  </p:cSld>
+  <p:clrMapOvr>
+    <a:masterClrMapping/>
+  </p:clrMapOvr>
+</p:sld>
+</file>
+
+<file path=ppt/slides/slide20.xml><?xml version="1.0" encoding="utf-8"?>
+<p:sld xmlns:a="http://schemas.openxmlformats.org/drawingml/2006/main" xmlns:p="http://schemas.openxmlformats.org/presentationml/2006/main" xmlns:r="http://schemas.openxmlformats.org/officeDocument/2006/relationships">
+  <p:cSld>
+    <p:spTree>
+      <p:nvGrpSpPr>
+        <p:cNvPr id="1" name=""/>
+        <p:cNvGrpSpPr/>
+        <p:nvPr/>
+      </p:nvGrpSpPr>
+      <p:grpSpPr/>
+      <p:sp>
+        <p:nvSpPr>
+          <p:cNvPr id="2" name="Text Placeholder 1"/>
+          <p:cNvSpPr>
+            <a:spLocks noGrp="1"/>
+          </p:cNvSpPr>
+          <p:nvPr>
+            <p:ph type="body" idx="13" sz="quarter"/>
+          </p:nvPr>
+        </p:nvSpPr>
+        <p:spPr/>
+        <p:txBody>
+          <a:bodyPr wrap="square"/>
+          <a:lstStyle/>
+          <a:p>
+            <a:r>
+              <a:t>¿Qué son los "parámetros" de un modelo?</a:t>
+            </a:r>
+          </a:p>
+        </p:txBody>
+      </p:sp>
+      <p:sp>
+        <p:nvSpPr>
+          <p:cNvPr id="3" name="Text Placeholder 2"/>
+          <p:cNvSpPr>
+            <a:spLocks noGrp="1"/>
+          </p:cNvSpPr>
+          <p:nvPr>
+            <p:ph type="body" idx="16" sz="quarter"/>
+          </p:nvPr>
+        </p:nvSpPr>
+        <p:spPr>
+          <a:xfrm>
+            <a:off x="1073427" y="2214736"/>
+            <a:ext cx="10084904" cy="3370138"/>
+          </a:xfrm>
+        </p:spPr>
+        <p:txBody>
+          <a:bodyPr wrap="square"/>
+          <a:lstStyle/>
+          <a:p>
+            <a:r>
+              <a:t>Los parámetros son los pesos numéricos que el modelo aprendió entrenando — NO son pasos ni iteraciones</a:t>
+            </a:r>
+          </a:p>
+          <a:p>
+            <a:r>
+              <a:t>qwen2.5:14b: 14.770.033.664 parámetros, repartidos en 48 capas fijas</a:t>
+            </a:r>
+          </a:p>
+          <a:p>
+            <a:r>
+              <a:t>En cada pasada (diapositiva anterior), TODOS los parámetros participan a la vez — en paralelo, no uno por uno</a:t>
+            </a:r>
+          </a:p>
+          <a:p>
+            <a:r>
+              <a:t>Lo que sí avanza paso a paso es la generación: una pasada por las 48 capas, por cada palabra nueva</a:t>
+            </a:r>
+          </a:p>
+        </p:txBody>
+      </p:sp>
+    </p:spTree>
+  </p:cSld>
+  <p:clrMapOvr>
+    <a:masterClrMapping/>
+  </p:clrMapOvr>
+</p:sld>
+</file>
+
+<file path=ppt/slides/slide21.xml><?xml version="1.0" encoding="utf-8"?>
 <p:sld xmlns:a="http://schemas.openxmlformats.org/drawingml/2006/main" xmlns:p="http://schemas.openxmlformats.org/presentationml/2006/main" xmlns:r="http://schemas.openxmlformats.org/officeDocument/2006/relationships">
   <p:cSld>
     <p:spTree>
@@ -7062,7 +8898,7 @@
 </p:sld>
 </file>
 
-<file path=ppt/slides/slide17.xml><?xml version="1.0" encoding="utf-8"?>
+<file path=ppt/slides/slide22.xml><?xml version="1.0" encoding="utf-8"?>
 <p:sld xmlns:a="http://schemas.openxmlformats.org/drawingml/2006/main" xmlns:p="http://schemas.openxmlformats.org/presentationml/2006/main" xmlns:r="http://schemas.openxmlformats.org/officeDocument/2006/relationships">
   <p:cSld>
     <p:spTree>
@@ -7088,7 +8924,7 @@
           <a:lstStyle/>
           <a:p>
             <a:r>
-              <a:t>Qué elegir: potencia vs. cómputo</a:t>
+              <a:t>Cuantización: qué le pasa a cada parámetro</a:t>
             </a:r>
           </a:p>
         </p:txBody>
@@ -7114,17 +8950,22 @@
           <a:lstStyle/>
           <a:p>
             <a:r>
-              <a:t>Modelo más grande = más capacidad, pero más RAM/VRAM y más lento</a:t>
-            </a:r>
-          </a:p>
-          <a:p>
-            <a:r>
-              <a:t>Cuantizar reduce tamaño y velocidad de carga, con pérdida de precisión asumible</a:t>
-            </a:r>
-          </a:p>
-          <a:p>
-            <a:r>
-              <a:t>Para tus propios proyectos: empieza pequeño, sube solo si de verdad lo necesitas</a:t>
+              <a:t>Cada uno de esos 14.770 millones de parámetros normalmente se guarda en FP16: 16 bits (2 bytes) por número</a:t>
+            </a:r>
+          </a:p>
+          <a:p>
+            <a:r>
+              <a:t>Cuantizar a Q4 = guardar cada parámetro con ~4 bits en vez de 16 — una versión "redondeada" del mismo número</a:t>
+            </a:r>
+          </a:p>
+          <a:p>
+            <a:r>
+              <a:t>Menos precisión por número × mismos 14.770 millones de números = mismo modelo, mucho menos peso</a:t>
+            </a:r>
+          </a:p>
+          <a:p>
+            <a:r>
+              <a:t>El nombre "Q4_K_M" que vimos en el notebook describe exactamente ESTA técnica de redondeo por bloques</a:t>
             </a:r>
           </a:p>
         </p:txBody>
@@ -7137,7 +8978,82 @@
 </p:sld>
 </file>
 
-<file path=ppt/slides/slide18.xml><?xml version="1.0" encoding="utf-8"?>
+<file path=ppt/slides/slide23.xml><?xml version="1.0" encoding="utf-8"?>
+<p:sld xmlns:a="http://schemas.openxmlformats.org/drawingml/2006/main" xmlns:p="http://schemas.openxmlformats.org/presentationml/2006/main" xmlns:r="http://schemas.openxmlformats.org/officeDocument/2006/relationships">
+  <p:cSld>
+    <p:spTree>
+      <p:nvGrpSpPr>
+        <p:cNvPr id="1" name=""/>
+        <p:cNvGrpSpPr/>
+        <p:nvPr/>
+      </p:nvGrpSpPr>
+      <p:grpSpPr/>
+      <p:sp>
+        <p:nvSpPr>
+          <p:cNvPr id="2" name="Text Placeholder 1"/>
+          <p:cNvSpPr>
+            <a:spLocks noGrp="1"/>
+          </p:cNvSpPr>
+          <p:nvPr>
+            <p:ph type="body" idx="13" sz="quarter"/>
+          </p:nvPr>
+        </p:nvSpPr>
+        <p:spPr/>
+        <p:txBody>
+          <a:bodyPr wrap="square"/>
+          <a:lstStyle/>
+          <a:p>
+            <a:r>
+              <a:t>Qué elegir: potencia vs. cómputo</a:t>
+            </a:r>
+          </a:p>
+        </p:txBody>
+      </p:sp>
+      <p:sp>
+        <p:nvSpPr>
+          <p:cNvPr id="3" name="Text Placeholder 2"/>
+          <p:cNvSpPr>
+            <a:spLocks noGrp="1"/>
+          </p:cNvSpPr>
+          <p:nvPr>
+            <p:ph type="body" idx="16" sz="quarter"/>
+          </p:nvPr>
+        </p:nvSpPr>
+        <p:spPr>
+          <a:xfrm>
+            <a:off x="1073427" y="2214736"/>
+            <a:ext cx="10084904" cy="3370138"/>
+          </a:xfrm>
+        </p:spPr>
+        <p:txBody>
+          <a:bodyPr wrap="square"/>
+          <a:lstStyle/>
+          <a:p>
+            <a:r>
+              <a:t>Modelo más grande = más capacidad, pero más RAM/VRAM y más lento</a:t>
+            </a:r>
+          </a:p>
+          <a:p>
+            <a:r>
+              <a:t>Cuantizar reduce tamaño y velocidad de carga, con pérdida de precisión asumible</a:t>
+            </a:r>
+          </a:p>
+          <a:p>
+            <a:r>
+              <a:t>Para tus propios proyectos: empieza pequeño, sube solo si de verdad lo necesitas</a:t>
+            </a:r>
+          </a:p>
+        </p:txBody>
+      </p:sp>
+    </p:spTree>
+  </p:cSld>
+  <p:clrMapOvr>
+    <a:masterClrMapping/>
+  </p:clrMapOvr>
+</p:sld>
+</file>
+
+<file path=ppt/slides/slide24.xml><?xml version="1.0" encoding="utf-8"?>
 <p:sld xmlns:a="http://schemas.openxmlformats.org/drawingml/2006/main" xmlns:p="http://schemas.openxmlformats.org/presentationml/2006/main" xmlns:r="http://schemas.openxmlformats.org/officeDocument/2006/relationships">
   <p:cSld>
     <p:spTree>
@@ -7252,7 +9168,7 @@
 </p:sld>
 </file>
 
-<file path=ppt/slides/slide19.xml><?xml version="1.0" encoding="utf-8"?>
+<file path=ppt/slides/slide25.xml><?xml version="1.0" encoding="utf-8"?>
 <p:sld xmlns:a="http://schemas.openxmlformats.org/drawingml/2006/main" xmlns:p="http://schemas.openxmlformats.org/presentationml/2006/main" xmlns:r="http://schemas.openxmlformats.org/officeDocument/2006/relationships">
   <p:cSld>
     <p:spTree>
@@ -7458,7 +9374,7 @@
 </p:sld>
 </file>
 
-<file path=ppt/slides/slide2.xml><?xml version="1.0" encoding="utf-8"?>
+<file path=ppt/slides/slide26.xml><?xml version="1.0" encoding="utf-8"?>
 <p:sld xmlns:a="http://schemas.openxmlformats.org/drawingml/2006/main" xmlns:p="http://schemas.openxmlformats.org/presentationml/2006/main" xmlns:r="http://schemas.openxmlformats.org/officeDocument/2006/relationships">
   <p:cSld>
     <p:spTree>
@@ -7491,13 +9407,13 @@
                 </a:solidFill>
                 <a:latin typeface="Arial"/>
               </a:rPr>
-              <a:t>SECCIÓN 1</a:t>
+              <a:t>SECCIÓN 4</a:t>
             </a:r>
           </a:p>
           <a:p>
             <a:pPr algn="ctr"/>
             <a:r>
-              <a:t>Gestión de dependencias con uv</a:t>
+              <a:t>El stack de análisis</a:t>
             </a:r>
           </a:p>
           <a:p>
@@ -7509,7 +9425,7 @@
                 </a:solidFill>
                 <a:latin typeface="Arial"/>
               </a:rPr>
-              <a:t>Sin magia, simple</a:t>
+              <a:t>Qué instala uv sync y para qué sirve cada pieza</a:t>
             </a:r>
           </a:p>
         </p:txBody>
@@ -7522,71 +9438,7 @@
 </p:sld>
 </file>
 
-<file path=ppt/slides/slide20.xml><?xml version="1.0" encoding="utf-8"?>
-<p:sld xmlns:a="http://schemas.openxmlformats.org/drawingml/2006/main" xmlns:p="http://schemas.openxmlformats.org/presentationml/2006/main" xmlns:r="http://schemas.openxmlformats.org/officeDocument/2006/relationships">
-  <p:cSld>
-    <p:spTree>
-      <p:nvGrpSpPr>
-        <p:cNvPr id="1" name=""/>
-        <p:cNvGrpSpPr/>
-        <p:nvPr/>
-      </p:nvGrpSpPr>
-      <p:grpSpPr/>
-      <p:sp>
-        <p:nvSpPr>
-          <p:cNvPr id="2" name="Text Placeholder 1"/>
-          <p:cNvSpPr>
-            <a:spLocks noGrp="1"/>
-          </p:cNvSpPr>
-          <p:nvPr>
-            <p:ph type="body" idx="10" sz="quarter"/>
-          </p:nvPr>
-        </p:nvSpPr>
-        <p:spPr/>
-        <p:txBody>
-          <a:bodyPr wrap="square"/>
-          <a:lstStyle/>
-          <a:p>
-            <a:pPr algn="ctr"/>
-            <a:r>
-              <a:rPr sz="1700" b="1">
-                <a:solidFill>
-                  <a:srgbClr val="CD2D37"/>
-                </a:solidFill>
-                <a:latin typeface="Arial"/>
-              </a:rPr>
-              <a:t>SECCIÓN 4</a:t>
-            </a:r>
-          </a:p>
-          <a:p>
-            <a:pPr algn="ctr"/>
-            <a:r>
-              <a:t>El stack de análisis</a:t>
-            </a:r>
-          </a:p>
-          <a:p>
-            <a:pPr algn="ctr"/>
-            <a:r>
-              <a:rPr sz="1600">
-                <a:solidFill>
-                  <a:srgbClr val="D6DAE2"/>
-                </a:solidFill>
-                <a:latin typeface="Arial"/>
-              </a:rPr>
-              <a:t>Qué instala uv sync y para qué sirve cada pieza</a:t>
-            </a:r>
-          </a:p>
-        </p:txBody>
-      </p:sp>
-    </p:spTree>
-  </p:cSld>
-  <p:clrMapOvr>
-    <a:masterClrMapping/>
-  </p:clrMapOvr>
-</p:sld>
-</file>
-
-<file path=ppt/slides/slide21.xml><?xml version="1.0" encoding="utf-8"?>
+<file path=ppt/slides/slide27.xml><?xml version="1.0" encoding="utf-8"?>
 <p:sld xmlns:a="http://schemas.openxmlformats.org/drawingml/2006/main" xmlns:p="http://schemas.openxmlformats.org/presentationml/2006/main" xmlns:r="http://schemas.openxmlformats.org/officeDocument/2006/relationships">
   <p:cSld>
     <p:spTree>
@@ -8025,7 +9877,7 @@
 </p:sld>
 </file>
 
-<file path=ppt/slides/slide22.xml><?xml version="1.0" encoding="utf-8"?>
+<file path=ppt/slides/slide28.xml><?xml version="1.0" encoding="utf-8"?>
 <p:sld xmlns:a="http://schemas.openxmlformats.org/drawingml/2006/main" xmlns:p="http://schemas.openxmlformats.org/presentationml/2006/main" xmlns:r="http://schemas.openxmlformats.org/officeDocument/2006/relationships">
   <p:cSld>
     <p:spTree>
@@ -8317,7 +10169,7 @@
 </p:sld>
 </file>
 
-<file path=ppt/slides/slide23.xml><?xml version="1.0" encoding="utf-8"?>
+<file path=ppt/slides/slide29.xml><?xml version="1.0" encoding="utf-8"?>
 <p:sld xmlns:a="http://schemas.openxmlformats.org/drawingml/2006/main" xmlns:p="http://schemas.openxmlformats.org/presentationml/2006/main" xmlns:r="http://schemas.openxmlformats.org/officeDocument/2006/relationships">
   <p:cSld>
     <p:spTree>

</xml_diff>

<commit_message>
fix(bloque3): quitar comentarios al instructor visibles en las diapositivas
Las notas dirigidas al instructor van en las notas del orador (notes=,
invisibles al proyectar), no en el texto visible de la diapositiva (note=).
Afectaba a "Ollama vs. llama.cpp" y "Modelos de Hugging Face en Ollama".
</commit_message>
<xml_diff>
--- a/bloque3_setup/csbc26_b3_setup.pptx
+++ b/bloque3_setup/csbc26_b3_setup.pptx
@@ -9331,41 +9331,6 @@
           </a:p>
         </p:txBody>
       </p:sp>
-      <p:sp>
-        <p:nvSpPr>
-          <p:cNvPr id="7" name="TextBox 6"/>
-          <p:cNvSpPr txBox="1"/>
-          <p:nvPr/>
-        </p:nvSpPr>
-        <p:spPr>
-          <a:xfrm>
-            <a:off x="1051560" y="5760720"/>
-            <a:ext cx="10058400" cy="365760"/>
-          </a:xfrm>
-          <a:prstGeom prst="rect">
-            <a:avLst/>
-          </a:prstGeom>
-          <a:noFill/>
-        </p:spPr>
-        <p:txBody>
-          <a:bodyPr wrap="square">
-            <a:spAutoFit/>
-          </a:bodyPr>
-          <a:lstStyle/>
-          <a:p>
-            <a:pPr algn="l"/>
-            <a:r>
-              <a:rPr sz="1100" b="0">
-                <a:solidFill>
-                  <a:srgbClr val="707888"/>
-                </a:solidFill>
-                <a:latin typeface="Arial"/>
-              </a:rPr>
-              <a:t>ℹ  Instructor: pausar aquí y buscar en vivo un modelo que pida el aula.</a:t>
-            </a:r>
-          </a:p>
-        </p:txBody>
-      </p:sp>
     </p:spTree>
   </p:cSld>
   <p:clrMapOvr>
@@ -12603,7 +12568,7 @@
                 </a:solidFill>
                 <a:latin typeface="Arial"/>
               </a:rPr>
-              <a:t>ℹ  Recomendación del instructor: Ollama — la comodidad casi no cuesta eficiencia.</a:t>
+              <a:t>ℹ  Recomendación: Ollama — la comodidad casi no cuesta eficiencia.</a:t>
             </a:r>
           </a:p>
         </p:txBody>

</xml_diff>